<commit_message>
A7 Unit 5 reviewed before shipping (Barton, adversarial, FAST educator — audit §8): the Q8 transfer surface pulled off the review and the 5.10 set; per-form key notes; Q3 and Q10 as FAST multiselects with the B1G-M misconceptions as choices; Q14 across systems; 'tanks the trip uses'; 5.04 teaches the scale from one pair before the exit asks it; US spellings; standard notes as the state writes them; kit prints Variation in the lines TE. 0 findings, installed, sheet 0 problems
Co-Authored-By: Claude Fable 5.1 <noreply@anthropic.com>
Claude-Session: https://claude.ai/code/session_01B7ovt6yLjh6QuFV9HBMV4N
</commit_message>
<xml_diff>
--- a/a7/build/out/u5/A7 5.01 Scale Drawings - Slides.pptx
+++ b/a7/build/out/u5/A7 5.01 Scale Drawings - Slides.pptx
@@ -3695,7 +3695,7 @@
                 </a:solidFill>
                 <a:latin typeface="Lexend"/>
               </a:rPr>
-              <a:t>A 6 cm by 8 cm rectangle is copied at 9 cm by 12 cm.</a:t>
+              <a:t>An 8 cm by 10 cm rectangle is copied at 12 cm by 15 cm.</a:t>
             </a:r>
           </a:p>
         </p:txBody>
@@ -3993,7 +3993,7 @@
                 </a:solidFill>
                 <a:latin typeface="Lexend"/>
               </a:rPr>
-              <a:t>A 6 cm by 8 cm rectangle is copied at 9 cm by 12 cm.</a:t>
+              <a:t>An 8 cm by 10 cm rectangle is copied at 12 cm by 15 cm.</a:t>
             </a:r>
           </a:p>
         </p:txBody>
@@ -4035,7 +4035,7 @@
       </p:sp>
       <p:pic>
         <p:nvPicPr>
-          <p:cNvPr id="10" name="Picture 9" descr="3c64e5c3ccc58708.png"/>
+          <p:cNvPr id="10" name="Picture 9" descr="fe7cf77f09050b1f.png"/>
           <p:cNvPicPr>
             <a:picLocks noChangeAspect="1"/>
           </p:cNvPicPr>
@@ -4049,8 +4049,8 @@
         </p:blipFill>
         <p:spPr>
           <a:xfrm>
-            <a:off x="4263966" y="2751548"/>
-            <a:ext cx="1502664" cy="609600"/>
+            <a:off x="4253298" y="2751548"/>
+            <a:ext cx="1673352" cy="603504"/>
           </a:xfrm>
           <a:prstGeom prst="rect">
             <a:avLst/>
@@ -4059,7 +4059,7 @@
       </p:pic>
       <p:pic>
         <p:nvPicPr>
-          <p:cNvPr id="11" name="Picture 10" descr="29d440c348e857de.png"/>
+          <p:cNvPr id="11" name="Picture 10" descr="ea6090423d2d6b79.png"/>
           <p:cNvPicPr>
             <a:picLocks noChangeAspect="1"/>
           </p:cNvPicPr>
@@ -4073,8 +4073,8 @@
         </p:blipFill>
         <p:spPr>
           <a:xfrm>
-            <a:off x="4263966" y="3489164"/>
-            <a:ext cx="1173480" cy="603504"/>
+            <a:off x="4253298" y="3483068"/>
+            <a:ext cx="1194816" cy="612648"/>
           </a:xfrm>
           <a:prstGeom prst="rect">
             <a:avLst/>
@@ -4089,7 +4089,7 @@
         </p:nvSpPr>
         <p:spPr>
           <a:xfrm>
-            <a:off x="5437446" y="3562316"/>
+            <a:off x="5448114" y="3560792"/>
             <a:ext cx="2710042" cy="457200"/>
           </a:xfrm>
           <a:prstGeom prst="rect">
@@ -4409,7 +4409,7 @@
                 </a:solidFill>
                 <a:latin typeface="Lexend"/>
               </a:rPr>
-              <a:t>A map's scale is 1 in : 20 mi. Two towns are 3.5 in apart on the map.</a:t>
+              <a:t>A map's scale is 1 in : 25 mi. Two towns are 2.6 in apart on the map.</a:t>
             </a:r>
           </a:p>
         </p:txBody>
@@ -4679,7 +4679,7 @@
       </p:sp>
       <p:pic>
         <p:nvPicPr>
-          <p:cNvPr id="8" name="Picture 7" descr="7911130c6d0faada.png"/>
+          <p:cNvPr id="8" name="Picture 7" descr="f31880d7c5f20662.png"/>
           <p:cNvPicPr>
             <a:picLocks noChangeAspect="1"/>
           </p:cNvPicPr>
@@ -4694,7 +4694,7 @@
         <p:spPr>
           <a:xfrm>
             <a:off x="1828800" y="1920240"/>
-            <a:ext cx="2072640" cy="277368"/>
+            <a:ext cx="2033015" cy="280416"/>
           </a:xfrm>
           <a:prstGeom prst="rect">
             <a:avLst/>
@@ -4731,7 +4731,7 @@
                 </a:solidFill>
                 <a:latin typeface="Lexend"/>
               </a:rPr>
-              <a:t>Answer:   70 mi</a:t>
+              <a:t>Answer:   65 mi</a:t>
             </a:r>
           </a:p>
         </p:txBody>
@@ -12170,7 +12170,7 @@
                 </a:solidFill>
                 <a:latin typeface="Lexend"/>
               </a:rPr>
-              <a:t>Dev, who is 13, draws a 12-ft wall as 3 in long.</a:t>
+              <a:t>Dev, who is 13, draws a 15-ft wall as 3 in long.</a:t>
             </a:r>
           </a:p>
         </p:txBody>
@@ -12503,7 +12503,7 @@
                 </a:solidFill>
                 <a:latin typeface="Lexend"/>
               </a:rPr>
-              <a:t>Dev, who is 13, draws a 12-ft wall as 3 in long.</a:t>
+              <a:t>Dev, who is 13, draws a 15-ft wall as 3 in long.</a:t>
             </a:r>
           </a:p>
         </p:txBody>
@@ -12545,7 +12545,7 @@
       </p:sp>
       <p:pic>
         <p:nvPicPr>
-          <p:cNvPr id="10" name="Picture 9" descr="2908f8b113149456.png"/>
+          <p:cNvPr id="10" name="Picture 9" descr="53b8b83f65f5ccbf.png"/>
           <p:cNvPicPr>
             <a:picLocks noChangeAspect="1"/>
           </p:cNvPicPr>
@@ -12559,8 +12559,8 @@
         </p:blipFill>
         <p:spPr>
           <a:xfrm>
-            <a:off x="3829320" y="3150836"/>
-            <a:ext cx="1389888" cy="252984"/>
+            <a:off x="3846582" y="3150836"/>
+            <a:ext cx="1374648" cy="252984"/>
           </a:xfrm>
           <a:prstGeom prst="rect">
             <a:avLst/>
@@ -12575,8 +12575,8 @@
         </p:nvSpPr>
         <p:spPr>
           <a:xfrm>
-            <a:off x="5219208" y="3048728"/>
-            <a:ext cx="3359878" cy="457200"/>
+            <a:off x="5221230" y="3048728"/>
+            <a:ext cx="3340595" cy="457200"/>
           </a:xfrm>
           <a:prstGeom prst="rect">
             <a:avLst/>
@@ -12597,14 +12597,14 @@
                 </a:solidFill>
                 <a:latin typeface="Lexend"/>
               </a:rPr>
-              <a:t>: every inch is 4 ft</a:t>
+              <a:t>: every inch is 5 ft</a:t>
             </a:r>
           </a:p>
         </p:txBody>
       </p:sp>
       <p:pic>
         <p:nvPicPr>
-          <p:cNvPr id="12" name="Picture 11" descr="62c8d8eef0eceabb.png"/>
+          <p:cNvPr id="12" name="Picture 11" descr="503b886175e4a464.png"/>
           <p:cNvPicPr>
             <a:picLocks noChangeAspect="1"/>
           </p:cNvPicPr>
@@ -12618,8 +12618,8 @@
         </p:blipFill>
         <p:spPr>
           <a:xfrm>
-            <a:off x="3829320" y="3690332"/>
-            <a:ext cx="1447800" cy="252984"/>
+            <a:off x="3846582" y="3690332"/>
+            <a:ext cx="1453896" cy="252984"/>
           </a:xfrm>
           <a:prstGeom prst="rect">
             <a:avLst/>
@@ -12656,7 +12656,7 @@
                 </a:solidFill>
                 <a:latin typeface="Lexend"/>
               </a:rPr>
-              <a:t>Answer:   5 in</a:t>
+              <a:t>Answer:   4 in</a:t>
             </a:r>
           </a:p>
         </p:txBody>
@@ -15433,7 +15433,7 @@
       </p:cxnSp>
       <p:pic>
         <p:nvPicPr>
-          <p:cNvPr id="10" name="Picture 9" descr="g260c4ca0095ac181.png"/>
+          <p:cNvPr id="10" name="Picture 9" descr="ga37466dfaa18789a.png"/>
           <p:cNvPicPr>
             <a:picLocks noChangeAspect="1"/>
           </p:cNvPicPr>
@@ -15447,8 +15447,8 @@
         </p:blipFill>
         <p:spPr>
           <a:xfrm>
-            <a:off x="3246120" y="1993392"/>
-            <a:ext cx="5669280" cy="2570073"/>
+            <a:off x="3611879" y="1993392"/>
+            <a:ext cx="4937760" cy="2238451"/>
           </a:xfrm>
           <a:prstGeom prst="rect">
             <a:avLst/>
@@ -15471,7 +15471,7 @@
         </p:blipFill>
         <p:spPr>
           <a:xfrm>
-            <a:off x="1670304" y="4709769"/>
+            <a:off x="1670304" y="4378147"/>
             <a:ext cx="8820912" cy="804672"/>
           </a:xfrm>
           <a:prstGeom prst="rect">
@@ -15479,6 +15479,41 @@
           </a:prstGeom>
         </p:spPr>
       </p:pic>
+      <p:sp>
+        <p:nvSpPr>
+          <p:cNvPr id="12" name="TextBox 11"/>
+          <p:cNvSpPr txBox="1"/>
+          <p:nvPr/>
+        </p:nvSpPr>
+        <p:spPr>
+          <a:xfrm>
+            <a:off x="987552" y="5521147"/>
+            <a:ext cx="10131551" cy="475488"/>
+          </a:xfrm>
+          <a:prstGeom prst="rect">
+            <a:avLst/>
+          </a:prstGeom>
+          <a:noFill/>
+        </p:spPr>
+        <p:txBody>
+          <a:bodyPr wrap="square" lIns="45720" rIns="45720" tIns="18288" bIns="18288" anchor="t">
+            <a:spAutoFit/>
+          </a:bodyPr>
+          <a:lstStyle/>
+          <a:p>
+            <a:pPr algn="l"/>
+            <a:r>
+              <a:rPr sz="2180" b="1" i="0">
+                <a:solidFill>
+                  <a:srgbClr val="1A1A1A"/>
+                </a:solidFill>
+                <a:latin typeface="Lexend"/>
+              </a:rPr>
+              <a:t>Every angle is still 90°: k multiplies lengths, not angles.</a:t>
+            </a:r>
+          </a:p>
+        </p:txBody>
+      </p:sp>
     </p:spTree>
   </p:cSld>
   <p:clrMapOvr>

</xml_diff>

<commit_message>
A7 Unit 5: the mathematics of every stem, board, prompt and choice typeset in LaTeX (Croix: 'rewrite the math to be in latex') — tools/texify_u5.py did the pass; title-slide boxes and asks stay plain; long math rows split into sentences; kit vendored (inline math on the baseline at text size; quantities as words on the Lexend papers). 0 findings, installed
Co-Authored-By: Claude Fable 5.1 <noreply@anthropic.com>
Claude-Session: https://claude.ai/code/session_01B7ovt6yLjh6QuFV9HBMV4N
</commit_message>
<xml_diff>
--- a/a7/build/out/u5/A7 5.01 Scale Drawings - Slides.pptx
+++ b/a7/build/out/u5/A7 5.01 Scale Drawings - Slides.pptx
@@ -4387,7 +4387,101 @@
         </p:nvSpPr>
         <p:spPr>
           <a:xfrm>
-            <a:off x="777240" y="2103120"/>
+            <a:off x="4060700" y="1714500"/>
+            <a:ext cx="2641202" cy="457200"/>
+          </a:xfrm>
+          <a:prstGeom prst="rect">
+            <a:avLst/>
+          </a:prstGeom>
+          <a:noFill/>
+        </p:spPr>
+        <p:txBody>
+          <a:bodyPr wrap="none" lIns="45720" rIns="45720" tIns="18288" bIns="18288" anchor="ctr">
+            <a:noAutofit/>
+          </a:bodyPr>
+          <a:lstStyle/>
+          <a:p>
+            <a:pPr algn="l"/>
+            <a:r>
+              <a:rPr sz="2280" b="0" i="0">
+                <a:solidFill>
+                  <a:srgbClr val="1A1A1A"/>
+                </a:solidFill>
+                <a:latin typeface="Lexend"/>
+              </a:rPr>
+              <a:t>A map's scale is </a:t>
+            </a:r>
+          </a:p>
+        </p:txBody>
+      </p:sp>
+      <p:pic>
+        <p:nvPicPr>
+          <p:cNvPr id="9" name="Picture 8" descr="d7f44fc30d54f3bb.png"/>
+          <p:cNvPicPr>
+            <a:picLocks noChangeAspect="1"/>
+          </p:cNvPicPr>
+          <p:nvPr/>
+        </p:nvPicPr>
+        <p:blipFill>
+          <a:blip r:embed="rId2"/>
+          <a:stretch>
+            <a:fillRect/>
+          </a:stretch>
+        </p:blipFill>
+        <p:spPr>
+          <a:xfrm>
+            <a:off x="6564742" y="1819656"/>
+            <a:ext cx="1392936" cy="243840"/>
+          </a:xfrm>
+          <a:prstGeom prst="rect">
+            <a:avLst/>
+          </a:prstGeom>
+        </p:spPr>
+      </p:pic>
+      <p:sp>
+        <p:nvSpPr>
+          <p:cNvPr id="10" name="TextBox 9"/>
+          <p:cNvSpPr txBox="1"/>
+          <p:nvPr/>
+        </p:nvSpPr>
+        <p:spPr>
+          <a:xfrm>
+            <a:off x="7957678" y="1714500"/>
+            <a:ext cx="280301" cy="457200"/>
+          </a:xfrm>
+          <a:prstGeom prst="rect">
+            <a:avLst/>
+          </a:prstGeom>
+          <a:noFill/>
+        </p:spPr>
+        <p:txBody>
+          <a:bodyPr wrap="none" lIns="45720" rIns="45720" tIns="18288" bIns="18288" anchor="ctr">
+            <a:noAutofit/>
+          </a:bodyPr>
+          <a:lstStyle/>
+          <a:p>
+            <a:pPr algn="l"/>
+            <a:r>
+              <a:rPr sz="2280" b="0" i="0">
+                <a:solidFill>
+                  <a:srgbClr val="1A1A1A"/>
+                </a:solidFill>
+                <a:latin typeface="Lexend"/>
+              </a:rPr>
+              <a:t>.</a:t>
+            </a:r>
+          </a:p>
+        </p:txBody>
+      </p:sp>
+      <p:sp>
+        <p:nvSpPr>
+          <p:cNvPr id="11" name="TextBox 10"/>
+          <p:cNvSpPr txBox="1"/>
+          <p:nvPr/>
+        </p:nvSpPr>
+        <p:spPr>
+          <a:xfrm>
+            <a:off x="777240" y="2423160"/>
             <a:ext cx="10607040" cy="429370"/>
           </a:xfrm>
           <a:prstGeom prst="rect">
@@ -4409,20 +4503,20 @@
                 </a:solidFill>
                 <a:latin typeface="Lexend"/>
               </a:rPr>
-              <a:t>A map's scale is 1 in : 25 mi. Two towns are 2.6 in apart on the map.</a:t>
-            </a:r>
-          </a:p>
-        </p:txBody>
-      </p:sp>
-      <p:sp>
-        <p:nvSpPr>
-          <p:cNvPr id="9" name="TextBox 8"/>
-          <p:cNvSpPr txBox="1"/>
-          <p:nvPr/>
-        </p:nvSpPr>
-        <p:spPr>
-          <a:xfrm>
-            <a:off x="777240" y="2825098"/>
+              <a:t>Two towns are 2.6 in apart on the map.</a:t>
+            </a:r>
+          </a:p>
+        </p:txBody>
+      </p:sp>
+      <p:sp>
+        <p:nvSpPr>
+          <p:cNvPr id="12" name="TextBox 11"/>
+          <p:cNvSpPr txBox="1"/>
+          <p:nvPr/>
+        </p:nvSpPr>
+        <p:spPr>
+          <a:xfrm>
+            <a:off x="777240" y="3145138"/>
             <a:ext cx="10607040" cy="429370"/>
           </a:xfrm>
           <a:prstGeom prst="rect">
@@ -4972,7 +5066,101 @@
         </p:nvSpPr>
         <p:spPr>
           <a:xfrm>
-            <a:off x="777240" y="1600200"/>
+            <a:off x="3931160" y="1577340"/>
+            <a:ext cx="2641202" cy="457200"/>
+          </a:xfrm>
+          <a:prstGeom prst="rect">
+            <a:avLst/>
+          </a:prstGeom>
+          <a:noFill/>
+        </p:spPr>
+        <p:txBody>
+          <a:bodyPr wrap="none" lIns="45720" rIns="45720" tIns="18288" bIns="18288" anchor="ctr">
+            <a:noAutofit/>
+          </a:bodyPr>
+          <a:lstStyle/>
+          <a:p>
+            <a:pPr algn="l"/>
+            <a:r>
+              <a:rPr sz="2280" b="0" i="0">
+                <a:solidFill>
+                  <a:srgbClr val="1A1A1A"/>
+                </a:solidFill>
+                <a:latin typeface="Lexend"/>
+              </a:rPr>
+              <a:t>A map's scale is </a:t>
+            </a:r>
+          </a:p>
+        </p:txBody>
+      </p:sp>
+      <p:pic>
+        <p:nvPicPr>
+          <p:cNvPr id="9" name="Picture 8" descr="06167158fe892fe2.png"/>
+          <p:cNvPicPr>
+            <a:picLocks noChangeAspect="1"/>
+          </p:cNvPicPr>
+          <p:nvPr/>
+        </p:nvPicPr>
+        <p:blipFill>
+          <a:blip r:embed="rId2"/>
+          <a:stretch>
+            <a:fillRect/>
+          </a:stretch>
+        </p:blipFill>
+        <p:spPr>
+          <a:xfrm>
+            <a:off x="6435202" y="1691640"/>
+            <a:ext cx="1652016" cy="234696"/>
+          </a:xfrm>
+          <a:prstGeom prst="rect">
+            <a:avLst/>
+          </a:prstGeom>
+        </p:spPr>
+      </p:pic>
+      <p:sp>
+        <p:nvSpPr>
+          <p:cNvPr id="10" name="TextBox 9"/>
+          <p:cNvSpPr txBox="1"/>
+          <p:nvPr/>
+        </p:nvSpPr>
+        <p:spPr>
+          <a:xfrm>
+            <a:off x="8087218" y="1577340"/>
+            <a:ext cx="280301" cy="457200"/>
+          </a:xfrm>
+          <a:prstGeom prst="rect">
+            <a:avLst/>
+          </a:prstGeom>
+          <a:noFill/>
+        </p:spPr>
+        <p:txBody>
+          <a:bodyPr wrap="none" lIns="45720" rIns="45720" tIns="18288" bIns="18288" anchor="ctr">
+            <a:noAutofit/>
+          </a:bodyPr>
+          <a:lstStyle/>
+          <a:p>
+            <a:pPr algn="l"/>
+            <a:r>
+              <a:rPr sz="2280" b="0" i="0">
+                <a:solidFill>
+                  <a:srgbClr val="1A1A1A"/>
+                </a:solidFill>
+                <a:latin typeface="Lexend"/>
+              </a:rPr>
+              <a:t>.</a:t>
+            </a:r>
+          </a:p>
+        </p:txBody>
+      </p:sp>
+      <p:sp>
+        <p:nvSpPr>
+          <p:cNvPr id="11" name="TextBox 10"/>
+          <p:cNvSpPr txBox="1"/>
+          <p:nvPr/>
+        </p:nvSpPr>
+        <p:spPr>
+          <a:xfrm>
+            <a:off x="777240" y="2286000"/>
             <a:ext cx="10607040" cy="429370"/>
           </a:xfrm>
           <a:prstGeom prst="rect">
@@ -4994,20 +5182,20 @@
                 </a:solidFill>
                 <a:latin typeface="Lexend"/>
               </a:rPr>
-              <a:t>A map's scale is 1 cm : 15 km. Two towns are 4.2 cm apart on the map.</a:t>
-            </a:r>
-          </a:p>
-        </p:txBody>
-      </p:sp>
-      <p:sp>
-        <p:nvSpPr>
-          <p:cNvPr id="9" name="TextBox 8"/>
-          <p:cNvSpPr txBox="1"/>
-          <p:nvPr/>
-        </p:nvSpPr>
-        <p:spPr>
-          <a:xfrm>
-            <a:off x="777240" y="2139298"/>
+              <a:t>Two towns are 4.2 cm apart on the map.</a:t>
+            </a:r>
+          </a:p>
+        </p:txBody>
+      </p:sp>
+      <p:sp>
+        <p:nvSpPr>
+          <p:cNvPr id="12" name="TextBox 11"/>
+          <p:cNvSpPr txBox="1"/>
+          <p:nvPr/>
+        </p:nvSpPr>
+        <p:spPr>
+          <a:xfrm>
+            <a:off x="777240" y="2825098"/>
             <a:ext cx="10607040" cy="429370"/>
           </a:xfrm>
           <a:prstGeom prst="rect">
@@ -5270,21 +5458,21 @@
         </p:nvSpPr>
         <p:spPr>
           <a:xfrm>
-            <a:off x="777240" y="1600200"/>
-            <a:ext cx="10607040" cy="429370"/>
-          </a:xfrm>
-          <a:prstGeom prst="rect">
-            <a:avLst/>
-          </a:prstGeom>
-          <a:noFill/>
-        </p:spPr>
-        <p:txBody>
-          <a:bodyPr wrap="square" lIns="45720" rIns="45720" tIns="18288" bIns="18288" anchor="t">
-            <a:spAutoFit/>
-          </a:bodyPr>
-          <a:lstStyle/>
-          <a:p>
-            <a:pPr algn="ctr"/>
+            <a:off x="3931160" y="1577340"/>
+            <a:ext cx="2641202" cy="457200"/>
+          </a:xfrm>
+          <a:prstGeom prst="rect">
+            <a:avLst/>
+          </a:prstGeom>
+          <a:noFill/>
+        </p:spPr>
+        <p:txBody>
+          <a:bodyPr wrap="none" lIns="45720" rIns="45720" tIns="18288" bIns="18288" anchor="ctr">
+            <a:noAutofit/>
+          </a:bodyPr>
+          <a:lstStyle/>
+          <a:p>
+            <a:pPr algn="l"/>
             <a:r>
               <a:rPr sz="2280" b="0" i="0">
                 <a:solidFill>
@@ -5292,49 +5480,14 @@
                 </a:solidFill>
                 <a:latin typeface="Lexend"/>
               </a:rPr>
-              <a:t>A map's scale is 1 cm : 15 km. Two towns are 4.2 cm apart on the map.</a:t>
-            </a:r>
-          </a:p>
-        </p:txBody>
-      </p:sp>
-      <p:sp>
-        <p:nvSpPr>
-          <p:cNvPr id="9" name="TextBox 8"/>
-          <p:cNvSpPr txBox="1"/>
-          <p:nvPr/>
-        </p:nvSpPr>
-        <p:spPr>
-          <a:xfrm>
-            <a:off x="777240" y="2139298"/>
-            <a:ext cx="10607040" cy="429370"/>
-          </a:xfrm>
-          <a:prstGeom prst="rect">
-            <a:avLst/>
-          </a:prstGeom>
-          <a:noFill/>
-        </p:spPr>
-        <p:txBody>
-          <a:bodyPr wrap="square" lIns="45720" rIns="45720" tIns="18288" bIns="18288" anchor="t">
-            <a:spAutoFit/>
-          </a:bodyPr>
-          <a:lstStyle/>
-          <a:p>
-            <a:pPr algn="ctr"/>
-            <a:r>
-              <a:rPr sz="2280" b="0" i="0">
-                <a:solidFill>
-                  <a:srgbClr val="1A1A1A"/>
-                </a:solidFill>
-                <a:latin typeface="Lexend"/>
-              </a:rPr>
-              <a:t>How far apart are the towns?</a:t>
+              <a:t>A map's scale is </a:t>
             </a:r>
           </a:p>
         </p:txBody>
       </p:sp>
       <p:pic>
         <p:nvPicPr>
-          <p:cNvPr id="10" name="Picture 9" descr="874fbb5c36f5222c.png"/>
+          <p:cNvPr id="9" name="Picture 8" descr="e2bec98e965b49e0.png"/>
           <p:cNvPicPr>
             <a:picLocks noChangeAspect="1"/>
           </p:cNvPicPr>
@@ -5348,7 +5501,136 @@
         </p:blipFill>
         <p:spPr>
           <a:xfrm>
-            <a:off x="5213603" y="2829272"/>
+            <a:off x="6435202" y="1691640"/>
+            <a:ext cx="1652016" cy="234696"/>
+          </a:xfrm>
+          <a:prstGeom prst="rect">
+            <a:avLst/>
+          </a:prstGeom>
+        </p:spPr>
+      </p:pic>
+      <p:sp>
+        <p:nvSpPr>
+          <p:cNvPr id="10" name="TextBox 9"/>
+          <p:cNvSpPr txBox="1"/>
+          <p:nvPr/>
+        </p:nvSpPr>
+        <p:spPr>
+          <a:xfrm>
+            <a:off x="8087218" y="1577340"/>
+            <a:ext cx="280301" cy="457200"/>
+          </a:xfrm>
+          <a:prstGeom prst="rect">
+            <a:avLst/>
+          </a:prstGeom>
+          <a:noFill/>
+        </p:spPr>
+        <p:txBody>
+          <a:bodyPr wrap="none" lIns="45720" rIns="45720" tIns="18288" bIns="18288" anchor="ctr">
+            <a:noAutofit/>
+          </a:bodyPr>
+          <a:lstStyle/>
+          <a:p>
+            <a:pPr algn="l"/>
+            <a:r>
+              <a:rPr sz="2280" b="0" i="0">
+                <a:solidFill>
+                  <a:srgbClr val="1A1A1A"/>
+                </a:solidFill>
+                <a:latin typeface="Lexend"/>
+              </a:rPr>
+              <a:t>.</a:t>
+            </a:r>
+          </a:p>
+        </p:txBody>
+      </p:sp>
+      <p:sp>
+        <p:nvSpPr>
+          <p:cNvPr id="11" name="TextBox 10"/>
+          <p:cNvSpPr txBox="1"/>
+          <p:nvPr/>
+        </p:nvSpPr>
+        <p:spPr>
+          <a:xfrm>
+            <a:off x="777240" y="2286000"/>
+            <a:ext cx="10607040" cy="429370"/>
+          </a:xfrm>
+          <a:prstGeom prst="rect">
+            <a:avLst/>
+          </a:prstGeom>
+          <a:noFill/>
+        </p:spPr>
+        <p:txBody>
+          <a:bodyPr wrap="square" lIns="45720" rIns="45720" tIns="18288" bIns="18288" anchor="t">
+            <a:spAutoFit/>
+          </a:bodyPr>
+          <a:lstStyle/>
+          <a:p>
+            <a:pPr algn="ctr"/>
+            <a:r>
+              <a:rPr sz="2280" b="0" i="0">
+                <a:solidFill>
+                  <a:srgbClr val="1A1A1A"/>
+                </a:solidFill>
+                <a:latin typeface="Lexend"/>
+              </a:rPr>
+              <a:t>Two towns are 4.2 cm apart on the map.</a:t>
+            </a:r>
+          </a:p>
+        </p:txBody>
+      </p:sp>
+      <p:sp>
+        <p:nvSpPr>
+          <p:cNvPr id="12" name="TextBox 11"/>
+          <p:cNvSpPr txBox="1"/>
+          <p:nvPr/>
+        </p:nvSpPr>
+        <p:spPr>
+          <a:xfrm>
+            <a:off x="777240" y="2825098"/>
+            <a:ext cx="10607040" cy="429370"/>
+          </a:xfrm>
+          <a:prstGeom prst="rect">
+            <a:avLst/>
+          </a:prstGeom>
+          <a:noFill/>
+        </p:spPr>
+        <p:txBody>
+          <a:bodyPr wrap="square" lIns="45720" rIns="45720" tIns="18288" bIns="18288" anchor="t">
+            <a:spAutoFit/>
+          </a:bodyPr>
+          <a:lstStyle/>
+          <a:p>
+            <a:pPr algn="ctr"/>
+            <a:r>
+              <a:rPr sz="2280" b="0" i="0">
+                <a:solidFill>
+                  <a:srgbClr val="1A1A1A"/>
+                </a:solidFill>
+                <a:latin typeface="Lexend"/>
+              </a:rPr>
+              <a:t>How far apart are the towns?</a:t>
+            </a:r>
+          </a:p>
+        </p:txBody>
+      </p:sp>
+      <p:pic>
+        <p:nvPicPr>
+          <p:cNvPr id="13" name="Picture 12" descr="874fbb5c36f5222c.png"/>
+          <p:cNvPicPr>
+            <a:picLocks noChangeAspect="1"/>
+          </p:cNvPicPr>
+          <p:nvPr/>
+        </p:nvPicPr>
+        <p:blipFill>
+          <a:blip r:embed="rId3"/>
+          <a:stretch>
+            <a:fillRect/>
+          </a:stretch>
+        </p:blipFill>
+        <p:spPr>
+          <a:xfrm>
+            <a:off x="5213603" y="3531265"/>
             <a:ext cx="1847088" cy="256032"/>
           </a:xfrm>
           <a:prstGeom prst="rect">
@@ -5358,7 +5640,7 @@
       </p:pic>
       <p:sp>
         <p:nvSpPr>
-          <p:cNvPr id="11" name="TextBox 10"/>
+          <p:cNvPr id="14" name="TextBox 13"/>
           <p:cNvSpPr txBox="1"/>
           <p:nvPr/>
         </p:nvSpPr>
@@ -7050,7 +7332,7 @@
         </p:blipFill>
         <p:spPr>
           <a:xfrm>
-            <a:off x="4659168" y="1527048"/>
+            <a:off x="4659168" y="1555813"/>
             <a:ext cx="1493520" cy="283464"/>
           </a:xfrm>
           <a:prstGeom prst="rect">
@@ -7109,7 +7391,7 @@
         </p:blipFill>
         <p:spPr>
           <a:xfrm>
-            <a:off x="4673306" y="2086356"/>
+            <a:off x="4673306" y="2083117"/>
             <a:ext cx="679704" cy="390144"/>
           </a:xfrm>
           <a:prstGeom prst="rect">
@@ -7168,7 +7450,7 @@
         </p:blipFill>
         <p:spPr>
           <a:xfrm>
-            <a:off x="3358447" y="2758440"/>
+            <a:off x="3358447" y="2738437"/>
             <a:ext cx="1130808" cy="271272"/>
           </a:xfrm>
           <a:prstGeom prst="rect">
@@ -8285,7 +8567,7 @@
         </p:blipFill>
         <p:spPr>
           <a:xfrm>
-            <a:off x="2258568" y="3156932"/>
+            <a:off x="2258568" y="3138644"/>
             <a:ext cx="478536" cy="277368"/>
           </a:xfrm>
           <a:prstGeom prst="rect">
@@ -8344,7 +8626,7 @@
         </p:blipFill>
         <p:spPr>
           <a:xfrm>
-            <a:off x="7104888" y="3156932"/>
+            <a:off x="7104888" y="3138644"/>
             <a:ext cx="530352" cy="277368"/>
           </a:xfrm>
           <a:prstGeom prst="rect">
@@ -8403,7 +8685,7 @@
         </p:blipFill>
         <p:spPr>
           <a:xfrm>
-            <a:off x="2258568" y="3771104"/>
+            <a:off x="2258568" y="3748244"/>
             <a:ext cx="137160" cy="274320"/>
           </a:xfrm>
           <a:prstGeom prst="rect">
@@ -8462,7 +8744,7 @@
         </p:blipFill>
         <p:spPr>
           <a:xfrm>
-            <a:off x="7104888" y="3771104"/>
+            <a:off x="7104888" y="3754340"/>
             <a:ext cx="185928" cy="274320"/>
           </a:xfrm>
           <a:prstGeom prst="rect">
@@ -9509,7 +9791,7 @@
         </p:blipFill>
         <p:spPr>
           <a:xfrm>
-            <a:off x="5327903" y="3149312"/>
+            <a:off x="5327903" y="3165505"/>
             <a:ext cx="1618488" cy="256032"/>
           </a:xfrm>
           <a:prstGeom prst="rect">
@@ -9788,17 +10070,17 @@
         </p:nvSpPr>
         <p:spPr>
           <a:xfrm>
-            <a:off x="1234440" y="1874519"/>
-            <a:ext cx="10058400" cy="858740"/>
-          </a:xfrm>
-          <a:prstGeom prst="rect">
-            <a:avLst/>
-          </a:prstGeom>
-          <a:noFill/>
-        </p:spPr>
-        <p:txBody>
-          <a:bodyPr wrap="square" lIns="45720" rIns="45720" tIns="18288" bIns="18288" anchor="t">
-            <a:spAutoFit/>
+            <a:off x="1234440" y="1851660"/>
+            <a:ext cx="9212348" cy="457200"/>
+          </a:xfrm>
+          <a:prstGeom prst="rect">
+            <a:avLst/>
+          </a:prstGeom>
+          <a:noFill/>
+        </p:spPr>
+        <p:txBody>
+          <a:bodyPr wrap="none" lIns="45720" rIns="45720" tIns="18288" bIns="18288" anchor="ctr">
+            <a:noAutofit/>
           </a:bodyPr>
           <a:lstStyle/>
           <a:p>
@@ -9810,84 +10092,14 @@
                 </a:solidFill>
                 <a:latin typeface="Lexend"/>
               </a:rPr>
-              <a:t>A drawing has a 40° angle. The real figure is a scale copy at k = 2.5.</a:t>
-            </a:r>
-          </a:p>
-        </p:txBody>
-      </p:sp>
-      <p:sp>
-        <p:nvSpPr>
-          <p:cNvPr id="9" name="TextBox 8"/>
-          <p:cNvSpPr txBox="1"/>
-          <p:nvPr/>
-        </p:nvSpPr>
-        <p:spPr>
-          <a:xfrm>
-            <a:off x="1234440" y="2842988"/>
-            <a:ext cx="10058400" cy="429370"/>
-          </a:xfrm>
-          <a:prstGeom prst="rect">
-            <a:avLst/>
-          </a:prstGeom>
-          <a:noFill/>
-        </p:spPr>
-        <p:txBody>
-          <a:bodyPr wrap="square" lIns="45720" rIns="45720" tIns="18288" bIns="18288" anchor="t">
-            <a:spAutoFit/>
-          </a:bodyPr>
-          <a:lstStyle/>
-          <a:p>
-            <a:pPr algn="l"/>
-            <a:r>
-              <a:rPr sz="2280" b="1" i="0">
-                <a:solidFill>
-                  <a:srgbClr val="1A1A1A"/>
-                </a:solidFill>
-                <a:latin typeface="Lexend"/>
-              </a:rPr>
-              <a:t>What is the angle in the real figure?</a:t>
-            </a:r>
-          </a:p>
-        </p:txBody>
-      </p:sp>
-      <p:sp>
-        <p:nvSpPr>
-          <p:cNvPr id="10" name="TextBox 9"/>
-          <p:cNvSpPr txBox="1"/>
-          <p:nvPr/>
-        </p:nvSpPr>
-        <p:spPr>
-          <a:xfrm>
-            <a:off x="1691640" y="3574111"/>
-            <a:ext cx="594360" cy="457200"/>
-          </a:xfrm>
-          <a:prstGeom prst="rect">
-            <a:avLst/>
-          </a:prstGeom>
-          <a:noFill/>
-        </p:spPr>
-        <p:txBody>
-          <a:bodyPr wrap="square" lIns="45720" rIns="45720" tIns="18288" bIns="18288" anchor="t">
-            <a:spAutoFit/>
-          </a:bodyPr>
-          <a:lstStyle/>
-          <a:p>
-            <a:pPr algn="l"/>
-            <a:r>
-              <a:rPr sz="2280" b="1" i="0">
-                <a:solidFill>
-                  <a:srgbClr val="1A1A1A"/>
-                </a:solidFill>
-                <a:latin typeface="Lexend"/>
-              </a:rPr>
-              <a:t>A.</a:t>
+              <a:t>A drawing has a 40° angle. The real figure is a scale copy at </a:t>
             </a:r>
           </a:p>
         </p:txBody>
       </p:sp>
       <p:pic>
         <p:nvPicPr>
-          <p:cNvPr id="11" name="Picture 10" descr="931d3a876917babd.png"/>
+          <p:cNvPr id="9" name="Picture 8" descr="fc22e08664d80881.png"/>
           <p:cNvPicPr>
             <a:picLocks noChangeAspect="1"/>
           </p:cNvPicPr>
@@ -9901,8 +10113,8 @@
         </p:blipFill>
         <p:spPr>
           <a:xfrm>
-            <a:off x="2258568" y="3586303"/>
-            <a:ext cx="600456" cy="277368"/>
+            <a:off x="10309628" y="1965960"/>
+            <a:ext cx="853440" cy="234696"/>
           </a:xfrm>
           <a:prstGeom prst="rect">
             <a:avLst/>
@@ -9911,13 +10123,83 @@
       </p:pic>
       <p:sp>
         <p:nvSpPr>
+          <p:cNvPr id="10" name="TextBox 9"/>
+          <p:cNvSpPr txBox="1"/>
+          <p:nvPr/>
+        </p:nvSpPr>
+        <p:spPr>
+          <a:xfrm>
+            <a:off x="11163068" y="1851660"/>
+            <a:ext cx="280301" cy="457200"/>
+          </a:xfrm>
+          <a:prstGeom prst="rect">
+            <a:avLst/>
+          </a:prstGeom>
+          <a:noFill/>
+        </p:spPr>
+        <p:txBody>
+          <a:bodyPr wrap="none" lIns="45720" rIns="45720" tIns="18288" bIns="18288" anchor="ctr">
+            <a:noAutofit/>
+          </a:bodyPr>
+          <a:lstStyle/>
+          <a:p>
+            <a:pPr algn="l"/>
+            <a:r>
+              <a:rPr sz="2280" b="0" i="0">
+                <a:solidFill>
+                  <a:srgbClr val="1A1A1A"/>
+                </a:solidFill>
+                <a:latin typeface="Lexend"/>
+              </a:rPr>
+              <a:t>.</a:t>
+            </a:r>
+          </a:p>
+        </p:txBody>
+      </p:sp>
+      <p:sp>
+        <p:nvSpPr>
+          <p:cNvPr id="11" name="TextBox 10"/>
+          <p:cNvSpPr txBox="1"/>
+          <p:nvPr/>
+        </p:nvSpPr>
+        <p:spPr>
+          <a:xfrm>
+            <a:off x="1234440" y="2487168"/>
+            <a:ext cx="10058400" cy="429370"/>
+          </a:xfrm>
+          <a:prstGeom prst="rect">
+            <a:avLst/>
+          </a:prstGeom>
+          <a:noFill/>
+        </p:spPr>
+        <p:txBody>
+          <a:bodyPr wrap="square" lIns="45720" rIns="45720" tIns="18288" bIns="18288" anchor="t">
+            <a:spAutoFit/>
+          </a:bodyPr>
+          <a:lstStyle/>
+          <a:p>
+            <a:pPr algn="l"/>
+            <a:r>
+              <a:rPr sz="2280" b="1" i="0">
+                <a:solidFill>
+                  <a:srgbClr val="1A1A1A"/>
+                </a:solidFill>
+                <a:latin typeface="Lexend"/>
+              </a:rPr>
+              <a:t>What is the angle in the real figure?</a:t>
+            </a:r>
+          </a:p>
+        </p:txBody>
+      </p:sp>
+      <p:sp>
+        <p:nvSpPr>
           <p:cNvPr id="12" name="TextBox 11"/>
           <p:cNvSpPr txBox="1"/>
           <p:nvPr/>
         </p:nvSpPr>
         <p:spPr>
           <a:xfrm>
-            <a:off x="6537959" y="3574111"/>
+            <a:off x="1691640" y="3218290"/>
             <a:ext cx="594360" cy="457200"/>
           </a:xfrm>
           <a:prstGeom prst="rect">
@@ -9939,14 +10221,14 @@
                 </a:solidFill>
                 <a:latin typeface="Lexend"/>
               </a:rPr>
-              <a:t>B.</a:t>
+              <a:t>A.</a:t>
             </a:r>
           </a:p>
         </p:txBody>
       </p:sp>
       <p:pic>
         <p:nvPicPr>
-          <p:cNvPr id="13" name="Picture 12" descr="f041d7103b8797df.png"/>
+          <p:cNvPr id="13" name="Picture 12" descr="931d3a876917babd.png"/>
           <p:cNvPicPr>
             <a:picLocks noChangeAspect="1"/>
           </p:cNvPicPr>
@@ -9960,8 +10242,8 @@
         </p:blipFill>
         <p:spPr>
           <a:xfrm>
-            <a:off x="7104888" y="3586303"/>
-            <a:ext cx="886968" cy="277368"/>
+            <a:off x="2258568" y="3212194"/>
+            <a:ext cx="600456" cy="277368"/>
           </a:xfrm>
           <a:prstGeom prst="rect">
             <a:avLst/>
@@ -9976,7 +10258,7 @@
         </p:nvSpPr>
         <p:spPr>
           <a:xfrm>
-            <a:off x="1691640" y="4186759"/>
+            <a:off x="6537959" y="3218290"/>
             <a:ext cx="594360" cy="457200"/>
           </a:xfrm>
           <a:prstGeom prst="rect">
@@ -9998,14 +10280,14 @@
                 </a:solidFill>
                 <a:latin typeface="Lexend"/>
               </a:rPr>
-              <a:t>C.</a:t>
+              <a:t>B.</a:t>
             </a:r>
           </a:p>
         </p:txBody>
       </p:sp>
       <p:pic>
         <p:nvPicPr>
-          <p:cNvPr id="15" name="Picture 14" descr="0b9eb51d2c267c3a.png"/>
+          <p:cNvPr id="15" name="Picture 14" descr="f041d7103b8797df.png"/>
           <p:cNvPicPr>
             <a:picLocks noChangeAspect="1"/>
           </p:cNvPicPr>
@@ -10019,8 +10301,8 @@
         </p:blipFill>
         <p:spPr>
           <a:xfrm>
-            <a:off x="2258568" y="4198951"/>
-            <a:ext cx="512064" cy="277368"/>
+            <a:off x="7104888" y="3212194"/>
+            <a:ext cx="886968" cy="277368"/>
           </a:xfrm>
           <a:prstGeom prst="rect">
             <a:avLst/>
@@ -10035,7 +10317,7 @@
         </p:nvSpPr>
         <p:spPr>
           <a:xfrm>
-            <a:off x="6537959" y="4186759"/>
+            <a:off x="1691640" y="3830938"/>
             <a:ext cx="594360" cy="457200"/>
           </a:xfrm>
           <a:prstGeom prst="rect">
@@ -10057,14 +10339,14 @@
                 </a:solidFill>
                 <a:latin typeface="Lexend"/>
               </a:rPr>
-              <a:t>D.</a:t>
+              <a:t>C.</a:t>
             </a:r>
           </a:p>
         </p:txBody>
       </p:sp>
       <p:pic>
         <p:nvPicPr>
-          <p:cNvPr id="17" name="Picture 16" descr="f6bdea168322aab5.png"/>
+          <p:cNvPr id="17" name="Picture 16" descr="0b9eb51d2c267c3a.png"/>
           <p:cNvPicPr>
             <a:picLocks noChangeAspect="1"/>
           </p:cNvPicPr>
@@ -10078,7 +10360,66 @@
         </p:blipFill>
         <p:spPr>
           <a:xfrm>
-            <a:off x="7104888" y="4198951"/>
+            <a:off x="2258568" y="3818746"/>
+            <a:ext cx="512064" cy="277368"/>
+          </a:xfrm>
+          <a:prstGeom prst="rect">
+            <a:avLst/>
+          </a:prstGeom>
+        </p:spPr>
+      </p:pic>
+      <p:sp>
+        <p:nvSpPr>
+          <p:cNvPr id="18" name="TextBox 17"/>
+          <p:cNvSpPr txBox="1"/>
+          <p:nvPr/>
+        </p:nvSpPr>
+        <p:spPr>
+          <a:xfrm>
+            <a:off x="6537959" y="3830938"/>
+            <a:ext cx="594360" cy="457200"/>
+          </a:xfrm>
+          <a:prstGeom prst="rect">
+            <a:avLst/>
+          </a:prstGeom>
+          <a:noFill/>
+        </p:spPr>
+        <p:txBody>
+          <a:bodyPr wrap="square" lIns="45720" rIns="45720" tIns="18288" bIns="18288" anchor="t">
+            <a:spAutoFit/>
+          </a:bodyPr>
+          <a:lstStyle/>
+          <a:p>
+            <a:pPr algn="l"/>
+            <a:r>
+              <a:rPr sz="2280" b="1" i="0">
+                <a:solidFill>
+                  <a:srgbClr val="1A1A1A"/>
+                </a:solidFill>
+                <a:latin typeface="Lexend"/>
+              </a:rPr>
+              <a:t>D.</a:t>
+            </a:r>
+          </a:p>
+        </p:txBody>
+      </p:sp>
+      <p:pic>
+        <p:nvPicPr>
+          <p:cNvPr id="19" name="Picture 18" descr="f6bdea168322aab5.png"/>
+          <p:cNvPicPr>
+            <a:picLocks noChangeAspect="1"/>
+          </p:cNvPicPr>
+          <p:nvPr/>
+        </p:nvPicPr>
+        <p:blipFill>
+          <a:blip r:embed="rId6"/>
+          <a:stretch>
+            <a:fillRect/>
+          </a:stretch>
+        </p:blipFill>
+        <p:spPr>
+          <a:xfrm>
+            <a:off x="7104888" y="3824842"/>
             <a:ext cx="765048" cy="277368"/>
           </a:xfrm>
           <a:prstGeom prst="rect">
@@ -10088,13 +10429,13 @@
       </p:pic>
       <p:sp>
         <p:nvSpPr>
-          <p:cNvPr id="18" name="TextBox 17"/>
-          <p:cNvSpPr txBox="1"/>
-          <p:nvPr/>
-        </p:nvSpPr>
-        <p:spPr>
-          <a:xfrm>
-            <a:off x="777240" y="4863415"/>
+          <p:cNvPr id="20" name="TextBox 19"/>
+          <p:cNvSpPr txBox="1"/>
+          <p:nvPr/>
+        </p:nvSpPr>
+        <p:spPr>
+          <a:xfrm>
+            <a:off x="777240" y="4507594"/>
             <a:ext cx="10607040" cy="457200"/>
           </a:xfrm>
           <a:prstGeom prst="rect">
@@ -10357,78 +10698,8 @@
         </p:nvSpPr>
         <p:spPr>
           <a:xfrm>
-            <a:off x="1234440" y="1874519"/>
-            <a:ext cx="10058400" cy="858740"/>
-          </a:xfrm>
-          <a:prstGeom prst="rect">
-            <a:avLst/>
-          </a:prstGeom>
-          <a:noFill/>
-        </p:spPr>
-        <p:txBody>
-          <a:bodyPr wrap="square" lIns="45720" rIns="45720" tIns="18288" bIns="18288" anchor="t">
-            <a:spAutoFit/>
-          </a:bodyPr>
-          <a:lstStyle/>
-          <a:p>
-            <a:pPr algn="l"/>
-            <a:r>
-              <a:rPr sz="2280" b="0" i="0">
-                <a:solidFill>
-                  <a:srgbClr val="1A1A1A"/>
-                </a:solidFill>
-                <a:latin typeface="Lexend"/>
-              </a:rPr>
-              <a:t>A drawing has a 40° angle. The real figure is a scale copy at k = 2.5.</a:t>
-            </a:r>
-          </a:p>
-        </p:txBody>
-      </p:sp>
-      <p:sp>
-        <p:nvSpPr>
-          <p:cNvPr id="9" name="TextBox 8"/>
-          <p:cNvSpPr txBox="1"/>
-          <p:nvPr/>
-        </p:nvSpPr>
-        <p:spPr>
-          <a:xfrm>
-            <a:off x="1234440" y="2842988"/>
-            <a:ext cx="10058400" cy="429370"/>
-          </a:xfrm>
-          <a:prstGeom prst="rect">
-            <a:avLst/>
-          </a:prstGeom>
-          <a:noFill/>
-        </p:spPr>
-        <p:txBody>
-          <a:bodyPr wrap="square" lIns="45720" rIns="45720" tIns="18288" bIns="18288" anchor="t">
-            <a:spAutoFit/>
-          </a:bodyPr>
-          <a:lstStyle/>
-          <a:p>
-            <a:pPr algn="l"/>
-            <a:r>
-              <a:rPr sz="2280" b="1" i="0">
-                <a:solidFill>
-                  <a:srgbClr val="1A1A1A"/>
-                </a:solidFill>
-                <a:latin typeface="Lexend"/>
-              </a:rPr>
-              <a:t>What is the angle in the real figure?</a:t>
-            </a:r>
-          </a:p>
-        </p:txBody>
-      </p:sp>
-      <p:sp>
-        <p:nvSpPr>
-          <p:cNvPr id="10" name="TextBox 9"/>
-          <p:cNvSpPr txBox="1"/>
-          <p:nvPr/>
-        </p:nvSpPr>
-        <p:spPr>
-          <a:xfrm>
-            <a:off x="2168098" y="3478099"/>
-            <a:ext cx="7962483" cy="457200"/>
+            <a:off x="1234440" y="1851660"/>
+            <a:ext cx="9212348" cy="457200"/>
           </a:xfrm>
           <a:prstGeom prst="rect">
             <a:avLst/>
@@ -10443,20 +10714,20 @@
           <a:p>
             <a:pPr algn="l"/>
             <a:r>
-              <a:rPr sz="2750" b="0" i="0">
+              <a:rPr sz="2280" b="0" i="0">
                 <a:solidFill>
                   <a:srgbClr val="1A1A1A"/>
                 </a:solidFill>
                 <a:latin typeface="Lexend"/>
               </a:rPr>
-              <a:t>Lengths are multiplied by k. Angles are not.</a:t>
+              <a:t>A drawing has a 40° angle. The real figure is a scale copy at </a:t>
             </a:r>
           </a:p>
         </p:txBody>
       </p:sp>
       <p:pic>
         <p:nvPicPr>
-          <p:cNvPr id="11" name="Picture 10" descr="3cc36cf75937c821.png"/>
+          <p:cNvPr id="9" name="Picture 8" descr="39705602679ca241.png"/>
           <p:cNvPicPr>
             <a:picLocks noChangeAspect="1"/>
           </p:cNvPicPr>
@@ -10470,7 +10741,136 @@
         </p:blipFill>
         <p:spPr>
           <a:xfrm>
-            <a:off x="2222962" y="4119703"/>
+            <a:off x="10309628" y="1965960"/>
+            <a:ext cx="853440" cy="234696"/>
+          </a:xfrm>
+          <a:prstGeom prst="rect">
+            <a:avLst/>
+          </a:prstGeom>
+        </p:spPr>
+      </p:pic>
+      <p:sp>
+        <p:nvSpPr>
+          <p:cNvPr id="10" name="TextBox 9"/>
+          <p:cNvSpPr txBox="1"/>
+          <p:nvPr/>
+        </p:nvSpPr>
+        <p:spPr>
+          <a:xfrm>
+            <a:off x="11163068" y="1851660"/>
+            <a:ext cx="280301" cy="457200"/>
+          </a:xfrm>
+          <a:prstGeom prst="rect">
+            <a:avLst/>
+          </a:prstGeom>
+          <a:noFill/>
+        </p:spPr>
+        <p:txBody>
+          <a:bodyPr wrap="none" lIns="45720" rIns="45720" tIns="18288" bIns="18288" anchor="ctr">
+            <a:noAutofit/>
+          </a:bodyPr>
+          <a:lstStyle/>
+          <a:p>
+            <a:pPr algn="l"/>
+            <a:r>
+              <a:rPr sz="2280" b="0" i="0">
+                <a:solidFill>
+                  <a:srgbClr val="1A1A1A"/>
+                </a:solidFill>
+                <a:latin typeface="Lexend"/>
+              </a:rPr>
+              <a:t>.</a:t>
+            </a:r>
+          </a:p>
+        </p:txBody>
+      </p:sp>
+      <p:sp>
+        <p:nvSpPr>
+          <p:cNvPr id="11" name="TextBox 10"/>
+          <p:cNvSpPr txBox="1"/>
+          <p:nvPr/>
+        </p:nvSpPr>
+        <p:spPr>
+          <a:xfrm>
+            <a:off x="1234440" y="2487168"/>
+            <a:ext cx="10058400" cy="429370"/>
+          </a:xfrm>
+          <a:prstGeom prst="rect">
+            <a:avLst/>
+          </a:prstGeom>
+          <a:noFill/>
+        </p:spPr>
+        <p:txBody>
+          <a:bodyPr wrap="square" lIns="45720" rIns="45720" tIns="18288" bIns="18288" anchor="t">
+            <a:spAutoFit/>
+          </a:bodyPr>
+          <a:lstStyle/>
+          <a:p>
+            <a:pPr algn="l"/>
+            <a:r>
+              <a:rPr sz="2280" b="1" i="0">
+                <a:solidFill>
+                  <a:srgbClr val="1A1A1A"/>
+                </a:solidFill>
+                <a:latin typeface="Lexend"/>
+              </a:rPr>
+              <a:t>What is the angle in the real figure?</a:t>
+            </a:r>
+          </a:p>
+        </p:txBody>
+      </p:sp>
+      <p:sp>
+        <p:nvSpPr>
+          <p:cNvPr id="12" name="TextBox 11"/>
+          <p:cNvSpPr txBox="1"/>
+          <p:nvPr/>
+        </p:nvSpPr>
+        <p:spPr>
+          <a:xfrm>
+            <a:off x="2168098" y="3122278"/>
+            <a:ext cx="7962483" cy="457200"/>
+          </a:xfrm>
+          <a:prstGeom prst="rect">
+            <a:avLst/>
+          </a:prstGeom>
+          <a:noFill/>
+        </p:spPr>
+        <p:txBody>
+          <a:bodyPr wrap="none" lIns="45720" rIns="45720" tIns="18288" bIns="18288" anchor="ctr">
+            <a:noAutofit/>
+          </a:bodyPr>
+          <a:lstStyle/>
+          <a:p>
+            <a:pPr algn="l"/>
+            <a:r>
+              <a:rPr sz="2750" b="0" i="0">
+                <a:solidFill>
+                  <a:srgbClr val="1A1A1A"/>
+                </a:solidFill>
+                <a:latin typeface="Lexend"/>
+              </a:rPr>
+              <a:t>Lengths are multiplied by k. Angles are not.</a:t>
+            </a:r>
+          </a:p>
+        </p:txBody>
+      </p:sp>
+      <p:pic>
+        <p:nvPicPr>
+          <p:cNvPr id="13" name="Picture 12" descr="3cc36cf75937c821.png"/>
+          <p:cNvPicPr>
+            <a:picLocks noChangeAspect="1"/>
+          </p:cNvPicPr>
+          <p:nvPr/>
+        </p:nvPicPr>
+        <p:blipFill>
+          <a:blip r:embed="rId3"/>
+          <a:stretch>
+            <a:fillRect/>
+          </a:stretch>
+        </p:blipFill>
+        <p:spPr>
+          <a:xfrm>
+            <a:off x="2222962" y="3781598"/>
             <a:ext cx="545592" cy="252984"/>
           </a:xfrm>
           <a:prstGeom prst="rect">
@@ -10480,7 +10880,7 @@
       </p:pic>
       <p:sp>
         <p:nvSpPr>
-          <p:cNvPr id="12" name="TextBox 11"/>
+          <p:cNvPr id="14" name="TextBox 13"/>
           <p:cNvSpPr txBox="1"/>
           <p:nvPr/>
         </p:nvSpPr>
@@ -11576,7 +11976,7 @@
         </p:blipFill>
         <p:spPr>
           <a:xfrm>
-            <a:off x="4659168" y="1527048"/>
+            <a:off x="4659168" y="1555813"/>
             <a:ext cx="1493520" cy="283464"/>
           </a:xfrm>
           <a:prstGeom prst="rect">
@@ -11670,7 +12070,7 @@
         </p:blipFill>
         <p:spPr>
           <a:xfrm>
-            <a:off x="4673306" y="2086356"/>
+            <a:off x="4673306" y="2083117"/>
             <a:ext cx="679704" cy="390144"/>
           </a:xfrm>
           <a:prstGeom prst="rect">
@@ -11764,7 +12164,7 @@
         </p:blipFill>
         <p:spPr>
           <a:xfrm>
-            <a:off x="3358447" y="2758440"/>
+            <a:off x="3358447" y="2738437"/>
             <a:ext cx="1130808" cy="271272"/>
           </a:xfrm>
           <a:prstGeom prst="rect">
@@ -12559,7 +12959,7 @@
         </p:blipFill>
         <p:spPr>
           <a:xfrm>
-            <a:off x="3846582" y="3150836"/>
+            <a:off x="3846582" y="3168553"/>
             <a:ext cx="1374648" cy="252984"/>
           </a:xfrm>
           <a:prstGeom prst="rect">
@@ -12618,7 +13018,7 @@
         </p:blipFill>
         <p:spPr>
           <a:xfrm>
-            <a:off x="3846582" y="3690332"/>
+            <a:off x="3846582" y="3708049"/>
             <a:ext cx="1453896" cy="252984"/>
           </a:xfrm>
           <a:prstGeom prst="rect">
@@ -13622,23 +14022,23 @@
         </p:nvSpPr>
         <p:spPr>
           <a:xfrm>
-            <a:off x="960120" y="1572768"/>
-            <a:ext cx="548640" cy="356616"/>
-          </a:xfrm>
-          <a:prstGeom prst="rect">
-            <a:avLst/>
-          </a:prstGeom>
-          <a:noFill/>
-        </p:spPr>
-        <p:txBody>
-          <a:bodyPr wrap="square" lIns="45720" rIns="45720" tIns="18288" bIns="18288" anchor="t">
-            <a:spAutoFit/>
-          </a:bodyPr>
-          <a:lstStyle/>
-          <a:p>
-            <a:pPr algn="l"/>
-            <a:r>
-              <a:rPr sz="1810" b="1" i="0">
+            <a:off x="960120" y="1497031"/>
+            <a:ext cx="548640" cy="417443"/>
+          </a:xfrm>
+          <a:prstGeom prst="rect">
+            <a:avLst/>
+          </a:prstGeom>
+          <a:noFill/>
+        </p:spPr>
+        <p:txBody>
+          <a:bodyPr wrap="square" lIns="45720" rIns="45720" tIns="18288" bIns="18288" anchor="ctr">
+            <a:spAutoFit/>
+          </a:bodyPr>
+          <a:lstStyle/>
+          <a:p>
+            <a:pPr algn="l"/>
+            <a:r>
+              <a:rPr sz="1989" b="1" i="0">
                 <a:solidFill>
                   <a:srgbClr val="0B5394"/>
                 </a:solidFill>
@@ -13657,23 +14057,23 @@
         </p:nvSpPr>
         <p:spPr>
           <a:xfrm>
-            <a:off x="1554480" y="1572768"/>
-            <a:ext cx="9829800" cy="411480"/>
-          </a:xfrm>
-          <a:prstGeom prst="rect">
-            <a:avLst/>
-          </a:prstGeom>
-          <a:noFill/>
-        </p:spPr>
-        <p:txBody>
-          <a:bodyPr wrap="square" lIns="45720" rIns="45720" tIns="18288" bIns="18288" anchor="t">
-            <a:spAutoFit/>
-          </a:bodyPr>
-          <a:lstStyle/>
-          <a:p>
-            <a:pPr algn="l"/>
-            <a:r>
-              <a:rPr sz="1810" b="0" i="0">
+            <a:off x="1554480" y="1497031"/>
+            <a:ext cx="8101712" cy="417443"/>
+          </a:xfrm>
+          <a:prstGeom prst="rect">
+            <a:avLst/>
+          </a:prstGeom>
+          <a:noFill/>
+        </p:spPr>
+        <p:txBody>
+          <a:bodyPr wrap="none" lIns="45720" rIns="45720" tIns="18288" bIns="18288" anchor="ctr">
+            <a:noAutofit/>
+          </a:bodyPr>
+          <a:lstStyle/>
+          <a:p>
+            <a:pPr algn="l"/>
+            <a:r>
+              <a:rPr sz="1989" b="0" i="0">
                 <a:solidFill>
                   <a:srgbClr val="1A1A1A"/>
                 </a:solidFill>
@@ -13692,23 +14092,23 @@
         </p:nvSpPr>
         <p:spPr>
           <a:xfrm>
-            <a:off x="960120" y="2075688"/>
-            <a:ext cx="548640" cy="356616"/>
-          </a:xfrm>
-          <a:prstGeom prst="rect">
-            <a:avLst/>
-          </a:prstGeom>
-          <a:noFill/>
-        </p:spPr>
-        <p:txBody>
-          <a:bodyPr wrap="square" lIns="45720" rIns="45720" tIns="18288" bIns="18288" anchor="t">
-            <a:spAutoFit/>
-          </a:bodyPr>
-          <a:lstStyle/>
-          <a:p>
-            <a:pPr algn="l"/>
-            <a:r>
-              <a:rPr sz="1810" b="1" i="0">
+            <a:off x="960120" y="2028178"/>
+            <a:ext cx="548640" cy="417443"/>
+          </a:xfrm>
+          <a:prstGeom prst="rect">
+            <a:avLst/>
+          </a:prstGeom>
+          <a:noFill/>
+        </p:spPr>
+        <p:txBody>
+          <a:bodyPr wrap="square" lIns="45720" rIns="45720" tIns="18288" bIns="18288" anchor="ctr">
+            <a:spAutoFit/>
+          </a:bodyPr>
+          <a:lstStyle/>
+          <a:p>
+            <a:pPr algn="l"/>
+            <a:r>
+              <a:rPr sz="1989" b="1" i="0">
                 <a:solidFill>
                   <a:srgbClr val="0B5394"/>
                 </a:solidFill>
@@ -13727,23 +14127,23 @@
         </p:nvSpPr>
         <p:spPr>
           <a:xfrm>
-            <a:off x="1554480" y="2075688"/>
-            <a:ext cx="9829800" cy="411480"/>
-          </a:xfrm>
-          <a:prstGeom prst="rect">
-            <a:avLst/>
-          </a:prstGeom>
-          <a:noFill/>
-        </p:spPr>
-        <p:txBody>
-          <a:bodyPr wrap="square" lIns="45720" rIns="45720" tIns="18288" bIns="18288" anchor="t">
-            <a:spAutoFit/>
-          </a:bodyPr>
-          <a:lstStyle/>
-          <a:p>
-            <a:pPr algn="l"/>
-            <a:r>
-              <a:rPr sz="1810" b="0" i="0">
+            <a:off x="1554480" y="2028178"/>
+            <a:ext cx="8098715" cy="417443"/>
+          </a:xfrm>
+          <a:prstGeom prst="rect">
+            <a:avLst/>
+          </a:prstGeom>
+          <a:noFill/>
+        </p:spPr>
+        <p:txBody>
+          <a:bodyPr wrap="none" lIns="45720" rIns="45720" tIns="18288" bIns="18288" anchor="ctr">
+            <a:noAutofit/>
+          </a:bodyPr>
+          <a:lstStyle/>
+          <a:p>
+            <a:pPr algn="l"/>
+            <a:r>
+              <a:rPr sz="1989" b="0" i="0">
                 <a:solidFill>
                   <a:srgbClr val="1A1A1A"/>
                 </a:solidFill>
@@ -13762,23 +14162,23 @@
         </p:nvSpPr>
         <p:spPr>
           <a:xfrm>
-            <a:off x="960120" y="2578608"/>
-            <a:ext cx="548640" cy="356616"/>
-          </a:xfrm>
-          <a:prstGeom prst="rect">
-            <a:avLst/>
-          </a:prstGeom>
-          <a:noFill/>
-        </p:spPr>
-        <p:txBody>
-          <a:bodyPr wrap="square" lIns="45720" rIns="45720" tIns="18288" bIns="18288" anchor="t">
-            <a:spAutoFit/>
-          </a:bodyPr>
-          <a:lstStyle/>
-          <a:p>
-            <a:pPr algn="l"/>
-            <a:r>
-              <a:rPr sz="1810" b="1" i="0">
+            <a:off x="960120" y="2559326"/>
+            <a:ext cx="548640" cy="417443"/>
+          </a:xfrm>
+          <a:prstGeom prst="rect">
+            <a:avLst/>
+          </a:prstGeom>
+          <a:noFill/>
+        </p:spPr>
+        <p:txBody>
+          <a:bodyPr wrap="square" lIns="45720" rIns="45720" tIns="18288" bIns="18288" anchor="ctr">
+            <a:spAutoFit/>
+          </a:bodyPr>
+          <a:lstStyle/>
+          <a:p>
+            <a:pPr algn="l"/>
+            <a:r>
+              <a:rPr sz="1989" b="1" i="0">
                 <a:solidFill>
                   <a:srgbClr val="0B5394"/>
                 </a:solidFill>
@@ -13797,29 +14197,29 @@
         </p:nvSpPr>
         <p:spPr>
           <a:xfrm>
-            <a:off x="1554480" y="2578608"/>
-            <a:ext cx="9829800" cy="411480"/>
-          </a:xfrm>
-          <a:prstGeom prst="rect">
-            <a:avLst/>
-          </a:prstGeom>
-          <a:noFill/>
-        </p:spPr>
-        <p:txBody>
-          <a:bodyPr wrap="square" lIns="45720" rIns="45720" tIns="18288" bIns="18288" anchor="t">
-            <a:spAutoFit/>
-          </a:bodyPr>
-          <a:lstStyle/>
-          <a:p>
-            <a:pPr algn="l"/>
-            <a:r>
-              <a:rPr sz="1810" b="0" i="0">
+            <a:off x="1554480" y="2559326"/>
+            <a:ext cx="9383799" cy="417443"/>
+          </a:xfrm>
+          <a:prstGeom prst="rect">
+            <a:avLst/>
+          </a:prstGeom>
+          <a:noFill/>
+        </p:spPr>
+        <p:txBody>
+          <a:bodyPr wrap="none" lIns="45720" rIns="45720" tIns="18288" bIns="18288" anchor="ctr">
+            <a:noAutofit/>
+          </a:bodyPr>
+          <a:lstStyle/>
+          <a:p>
+            <a:pPr algn="l"/>
+            <a:r>
+              <a:rPr sz="1989" b="0" i="0">
                 <a:solidFill>
                   <a:srgbClr val="1A1A1A"/>
                 </a:solidFill>
                 <a:latin typeface="Lexend"/>
               </a:rPr>
-              <a:t>A 3 cm by 5 cm rectangle is copied at 7.5 cm by 12.5 cm. Find the scale factor.</a:t>
+              <a:t>A 3 cm by 5 cm rectangle is copied at 7.5 cm by 12.5 cm. Find the scale </a:t>
             </a:r>
           </a:p>
         </p:txBody>
@@ -13832,23 +14232,58 @@
         </p:nvSpPr>
         <p:spPr>
           <a:xfrm>
-            <a:off x="960120" y="3081528"/>
-            <a:ext cx="548640" cy="356616"/>
-          </a:xfrm>
-          <a:prstGeom prst="rect">
-            <a:avLst/>
-          </a:prstGeom>
-          <a:noFill/>
-        </p:spPr>
-        <p:txBody>
-          <a:bodyPr wrap="square" lIns="45720" rIns="45720" tIns="18288" bIns="18288" anchor="t">
-            <a:spAutoFit/>
-          </a:bodyPr>
-          <a:lstStyle/>
-          <a:p>
-            <a:pPr algn="l"/>
-            <a:r>
-              <a:rPr sz="1810" b="1" i="0">
+            <a:off x="1554480" y="2962457"/>
+            <a:ext cx="1029950" cy="417443"/>
+          </a:xfrm>
+          <a:prstGeom prst="rect">
+            <a:avLst/>
+          </a:prstGeom>
+          <a:noFill/>
+        </p:spPr>
+        <p:txBody>
+          <a:bodyPr wrap="none" lIns="45720" rIns="45720" tIns="18288" bIns="18288" anchor="ctr">
+            <a:noAutofit/>
+          </a:bodyPr>
+          <a:lstStyle/>
+          <a:p>
+            <a:pPr algn="l"/>
+            <a:r>
+              <a:rPr sz="1989" b="0" i="0">
+                <a:solidFill>
+                  <a:srgbClr val="1A1A1A"/>
+                </a:solidFill>
+                <a:latin typeface="Lexend"/>
+              </a:rPr>
+              <a:t>factor.</a:t>
+            </a:r>
+          </a:p>
+        </p:txBody>
+      </p:sp>
+      <p:sp>
+        <p:nvSpPr>
+          <p:cNvPr id="15" name="TextBox 14"/>
+          <p:cNvSpPr txBox="1"/>
+          <p:nvPr/>
+        </p:nvSpPr>
+        <p:spPr>
+          <a:xfrm>
+            <a:off x="960120" y="3493604"/>
+            <a:ext cx="548640" cy="417443"/>
+          </a:xfrm>
+          <a:prstGeom prst="rect">
+            <a:avLst/>
+          </a:prstGeom>
+          <a:noFill/>
+        </p:spPr>
+        <p:txBody>
+          <a:bodyPr wrap="square" lIns="45720" rIns="45720" tIns="18288" bIns="18288" anchor="ctr">
+            <a:spAutoFit/>
+          </a:bodyPr>
+          <a:lstStyle/>
+          <a:p>
+            <a:pPr algn="l"/>
+            <a:r>
+              <a:rPr sz="1989" b="1" i="0">
                 <a:solidFill>
                   <a:srgbClr val="0B5394"/>
                 </a:solidFill>
@@ -13861,64 +14296,99 @@
       </p:sp>
       <p:sp>
         <p:nvSpPr>
-          <p:cNvPr id="15" name="TextBox 14"/>
-          <p:cNvSpPr txBox="1"/>
-          <p:nvPr/>
-        </p:nvSpPr>
-        <p:spPr>
-          <a:xfrm>
-            <a:off x="1554480" y="3081528"/>
-            <a:ext cx="9829800" cy="768096"/>
-          </a:xfrm>
-          <a:prstGeom prst="rect">
-            <a:avLst/>
-          </a:prstGeom>
-          <a:noFill/>
-        </p:spPr>
-        <p:txBody>
-          <a:bodyPr wrap="square" lIns="45720" rIns="45720" tIns="18288" bIns="18288" anchor="t">
-            <a:spAutoFit/>
-          </a:bodyPr>
-          <a:lstStyle/>
-          <a:p>
-            <a:pPr algn="l"/>
-            <a:r>
-              <a:rPr sz="1810" b="0" i="0">
+          <p:cNvPr id="16" name="TextBox 15"/>
+          <p:cNvSpPr txBox="1"/>
+          <p:nvPr/>
+        </p:nvSpPr>
+        <p:spPr>
+          <a:xfrm>
+            <a:off x="1554480" y="3493604"/>
+            <a:ext cx="9614649" cy="417443"/>
+          </a:xfrm>
+          <a:prstGeom prst="rect">
+            <a:avLst/>
+          </a:prstGeom>
+          <a:noFill/>
+        </p:spPr>
+        <p:txBody>
+          <a:bodyPr wrap="none" lIns="45720" rIns="45720" tIns="18288" bIns="18288" anchor="ctr">
+            <a:noAutofit/>
+          </a:bodyPr>
+          <a:lstStyle/>
+          <a:p>
+            <a:pPr algn="l"/>
+            <a:r>
+              <a:rPr sz="1989" b="0" i="0">
                 <a:solidFill>
                   <a:srgbClr val="1A1A1A"/>
                 </a:solidFill>
                 <a:latin typeface="Lexend"/>
               </a:rPr>
-              <a:t>The scale factor is 1.5 and a side of the original is 8 cm. How long is that side in the copy?</a:t>
-            </a:r>
-          </a:p>
-        </p:txBody>
-      </p:sp>
-      <p:sp>
-        <p:nvSpPr>
-          <p:cNvPr id="16" name="TextBox 15"/>
-          <p:cNvSpPr txBox="1"/>
-          <p:nvPr/>
-        </p:nvSpPr>
-        <p:spPr>
-          <a:xfrm>
-            <a:off x="960120" y="3941064"/>
-            <a:ext cx="548640" cy="356616"/>
-          </a:xfrm>
-          <a:prstGeom prst="rect">
-            <a:avLst/>
-          </a:prstGeom>
-          <a:noFill/>
-        </p:spPr>
-        <p:txBody>
-          <a:bodyPr wrap="square" lIns="45720" rIns="45720" tIns="18288" bIns="18288" anchor="t">
-            <a:spAutoFit/>
-          </a:bodyPr>
-          <a:lstStyle/>
-          <a:p>
-            <a:pPr algn="l"/>
-            <a:r>
-              <a:rPr sz="1810" b="1" i="0">
+              <a:t>The scale factor is 1.5 and a side of the original is 8 cm. How long is that </a:t>
+            </a:r>
+          </a:p>
+        </p:txBody>
+      </p:sp>
+      <p:sp>
+        <p:nvSpPr>
+          <p:cNvPr id="17" name="TextBox 16"/>
+          <p:cNvSpPr txBox="1"/>
+          <p:nvPr/>
+        </p:nvSpPr>
+        <p:spPr>
+          <a:xfrm>
+            <a:off x="1554480" y="3896735"/>
+            <a:ext cx="2387722" cy="417443"/>
+          </a:xfrm>
+          <a:prstGeom prst="rect">
+            <a:avLst/>
+          </a:prstGeom>
+          <a:noFill/>
+        </p:spPr>
+        <p:txBody>
+          <a:bodyPr wrap="none" lIns="45720" rIns="45720" tIns="18288" bIns="18288" anchor="ctr">
+            <a:noAutofit/>
+          </a:bodyPr>
+          <a:lstStyle/>
+          <a:p>
+            <a:pPr algn="l"/>
+            <a:r>
+              <a:rPr sz="1989" b="0" i="0">
+                <a:solidFill>
+                  <a:srgbClr val="1A1A1A"/>
+                </a:solidFill>
+                <a:latin typeface="Lexend"/>
+              </a:rPr>
+              <a:t>side in the copy?</a:t>
+            </a:r>
+          </a:p>
+        </p:txBody>
+      </p:sp>
+      <p:sp>
+        <p:nvSpPr>
+          <p:cNvPr id="18" name="TextBox 17"/>
+          <p:cNvSpPr txBox="1"/>
+          <p:nvPr/>
+        </p:nvSpPr>
+        <p:spPr>
+          <a:xfrm>
+            <a:off x="960120" y="4427882"/>
+            <a:ext cx="548640" cy="417443"/>
+          </a:xfrm>
+          <a:prstGeom prst="rect">
+            <a:avLst/>
+          </a:prstGeom>
+          <a:noFill/>
+        </p:spPr>
+        <p:txBody>
+          <a:bodyPr wrap="square" lIns="45720" rIns="45720" tIns="18288" bIns="18288" anchor="ctr">
+            <a:spAutoFit/>
+          </a:bodyPr>
+          <a:lstStyle/>
+          <a:p>
+            <a:pPr algn="l"/>
+            <a:r>
+              <a:rPr sz="1989" b="1" i="0">
                 <a:solidFill>
                   <a:srgbClr val="0B5394"/>
                 </a:solidFill>
@@ -13931,64 +14401,158 @@
       </p:sp>
       <p:sp>
         <p:nvSpPr>
-          <p:cNvPr id="17" name="TextBox 16"/>
-          <p:cNvSpPr txBox="1"/>
-          <p:nvPr/>
-        </p:nvSpPr>
-        <p:spPr>
-          <a:xfrm>
-            <a:off x="1554480" y="3941064"/>
-            <a:ext cx="9829800" cy="768096"/>
-          </a:xfrm>
-          <a:prstGeom prst="rect">
-            <a:avLst/>
-          </a:prstGeom>
-          <a:noFill/>
-        </p:spPr>
-        <p:txBody>
-          <a:bodyPr wrap="square" lIns="45720" rIns="45720" tIns="18288" bIns="18288" anchor="t">
-            <a:spAutoFit/>
-          </a:bodyPr>
-          <a:lstStyle/>
-          <a:p>
-            <a:pPr algn="l"/>
-            <a:r>
-              <a:rPr sz="1810" b="0" i="0">
+          <p:cNvPr id="19" name="TextBox 18"/>
+          <p:cNvSpPr txBox="1"/>
+          <p:nvPr/>
+        </p:nvSpPr>
+        <p:spPr>
+          <a:xfrm>
+            <a:off x="1554480" y="4427882"/>
+            <a:ext cx="2337215" cy="417443"/>
+          </a:xfrm>
+          <a:prstGeom prst="rect">
+            <a:avLst/>
+          </a:prstGeom>
+          <a:noFill/>
+        </p:spPr>
+        <p:txBody>
+          <a:bodyPr wrap="none" lIns="45720" rIns="45720" tIns="18288" bIns="18288" anchor="ctr">
+            <a:noAutofit/>
+          </a:bodyPr>
+          <a:lstStyle/>
+          <a:p>
+            <a:pPr algn="l"/>
+            <a:r>
+              <a:rPr sz="1989" b="0" i="0">
                 <a:solidFill>
                   <a:srgbClr val="1A1A1A"/>
                 </a:solidFill>
                 <a:latin typeface="Lexend"/>
               </a:rPr>
-              <a:t>A map's scale is 1 in : 25 mi. Two cities are 2.8 in apart on the map. How far apart are they?</a:t>
-            </a:r>
-          </a:p>
-        </p:txBody>
-      </p:sp>
-      <p:sp>
-        <p:nvSpPr>
-          <p:cNvPr id="18" name="TextBox 17"/>
-          <p:cNvSpPr txBox="1"/>
-          <p:nvPr/>
-        </p:nvSpPr>
-        <p:spPr>
-          <a:xfrm>
-            <a:off x="960120" y="4800600"/>
-            <a:ext cx="548640" cy="356616"/>
-          </a:xfrm>
-          <a:prstGeom prst="rect">
-            <a:avLst/>
-          </a:prstGeom>
-          <a:noFill/>
-        </p:spPr>
-        <p:txBody>
-          <a:bodyPr wrap="square" lIns="45720" rIns="45720" tIns="18288" bIns="18288" anchor="t">
-            <a:spAutoFit/>
-          </a:bodyPr>
-          <a:lstStyle/>
-          <a:p>
-            <a:pPr algn="l"/>
-            <a:r>
-              <a:rPr sz="1810" b="1" i="0">
+              <a:t>A map's scale is </a:t>
+            </a:r>
+          </a:p>
+        </p:txBody>
+      </p:sp>
+      <p:pic>
+        <p:nvPicPr>
+          <p:cNvPr id="20" name="Picture 19" descr="d7f44fc30d54f3bb.png"/>
+          <p:cNvPicPr>
+            <a:picLocks noChangeAspect="1"/>
+          </p:cNvPicPr>
+          <p:nvPr/>
+        </p:nvPicPr>
+        <p:blipFill>
+          <a:blip r:embed="rId2"/>
+          <a:stretch>
+            <a:fillRect/>
+          </a:stretch>
+        </p:blipFill>
+        <p:spPr>
+          <a:xfrm>
+            <a:off x="3754535" y="4525286"/>
+            <a:ext cx="1271811" cy="222636"/>
+          </a:xfrm>
+          <a:prstGeom prst="rect">
+            <a:avLst/>
+          </a:prstGeom>
+        </p:spPr>
+      </p:pic>
+      <p:sp>
+        <p:nvSpPr>
+          <p:cNvPr id="21" name="TextBox 20"/>
+          <p:cNvSpPr txBox="1"/>
+          <p:nvPr/>
+        </p:nvSpPr>
+        <p:spPr>
+          <a:xfrm>
+            <a:off x="5026347" y="4427882"/>
+            <a:ext cx="6472926" cy="417443"/>
+          </a:xfrm>
+          <a:prstGeom prst="rect">
+            <a:avLst/>
+          </a:prstGeom>
+          <a:noFill/>
+        </p:spPr>
+        <p:txBody>
+          <a:bodyPr wrap="none" lIns="45720" rIns="45720" tIns="18288" bIns="18288" anchor="ctr">
+            <a:noAutofit/>
+          </a:bodyPr>
+          <a:lstStyle/>
+          <a:p>
+            <a:pPr algn="l"/>
+            <a:r>
+              <a:rPr sz="1989" b="0" i="0">
+                <a:solidFill>
+                  <a:srgbClr val="1A1A1A"/>
+                </a:solidFill>
+                <a:latin typeface="Lexend"/>
+              </a:rPr>
+              <a:t>. Two cities are 2.8 in apart on the map. How far </a:t>
+            </a:r>
+          </a:p>
+        </p:txBody>
+      </p:sp>
+      <p:sp>
+        <p:nvSpPr>
+          <p:cNvPr id="22" name="TextBox 21"/>
+          <p:cNvSpPr txBox="1"/>
+          <p:nvPr/>
+        </p:nvSpPr>
+        <p:spPr>
+          <a:xfrm>
+            <a:off x="1554480" y="4831013"/>
+            <a:ext cx="2227461" cy="417443"/>
+          </a:xfrm>
+          <a:prstGeom prst="rect">
+            <a:avLst/>
+          </a:prstGeom>
+          <a:noFill/>
+        </p:spPr>
+        <p:txBody>
+          <a:bodyPr wrap="none" lIns="45720" rIns="45720" tIns="18288" bIns="18288" anchor="ctr">
+            <a:noAutofit/>
+          </a:bodyPr>
+          <a:lstStyle/>
+          <a:p>
+            <a:pPr algn="l"/>
+            <a:r>
+              <a:rPr sz="1989" b="0" i="0">
+                <a:solidFill>
+                  <a:srgbClr val="1A1A1A"/>
+                </a:solidFill>
+                <a:latin typeface="Lexend"/>
+              </a:rPr>
+              <a:t>apart are they?</a:t>
+            </a:r>
+          </a:p>
+        </p:txBody>
+      </p:sp>
+      <p:sp>
+        <p:nvSpPr>
+          <p:cNvPr id="23" name="TextBox 22"/>
+          <p:cNvSpPr txBox="1"/>
+          <p:nvPr/>
+        </p:nvSpPr>
+        <p:spPr>
+          <a:xfrm>
+            <a:off x="960120" y="5362160"/>
+            <a:ext cx="548640" cy="417443"/>
+          </a:xfrm>
+          <a:prstGeom prst="rect">
+            <a:avLst/>
+          </a:prstGeom>
+          <a:noFill/>
+        </p:spPr>
+        <p:txBody>
+          <a:bodyPr wrap="square" lIns="45720" rIns="45720" tIns="18288" bIns="18288" anchor="ctr">
+            <a:spAutoFit/>
+          </a:bodyPr>
+          <a:lstStyle/>
+          <a:p>
+            <a:pPr algn="l"/>
+            <a:r>
+              <a:rPr sz="1989" b="1" i="0">
                 <a:solidFill>
                   <a:srgbClr val="0B5394"/>
                 </a:solidFill>
@@ -14001,29 +14565,29 @@
       </p:sp>
       <p:sp>
         <p:nvSpPr>
-          <p:cNvPr id="19" name="TextBox 18"/>
-          <p:cNvSpPr txBox="1"/>
-          <p:nvPr/>
-        </p:nvSpPr>
-        <p:spPr>
-          <a:xfrm>
-            <a:off x="1554480" y="4800600"/>
-            <a:ext cx="9829800" cy="411480"/>
-          </a:xfrm>
-          <a:prstGeom prst="rect">
-            <a:avLst/>
-          </a:prstGeom>
-          <a:noFill/>
-        </p:spPr>
-        <p:txBody>
-          <a:bodyPr wrap="square" lIns="45720" rIns="45720" tIns="18288" bIns="18288" anchor="t">
-            <a:spAutoFit/>
-          </a:bodyPr>
-          <a:lstStyle/>
-          <a:p>
-            <a:pPr algn="l"/>
-            <a:r>
-              <a:rPr sz="1810" b="0" i="0">
+          <p:cNvPr id="24" name="TextBox 23"/>
+          <p:cNvSpPr txBox="1"/>
+          <p:nvPr/>
+        </p:nvSpPr>
+        <p:spPr>
+          <a:xfrm>
+            <a:off x="1554480" y="5362160"/>
+            <a:ext cx="8936737" cy="417443"/>
+          </a:xfrm>
+          <a:prstGeom prst="rect">
+            <a:avLst/>
+          </a:prstGeom>
+          <a:noFill/>
+        </p:spPr>
+        <p:txBody>
+          <a:bodyPr wrap="none" lIns="45720" rIns="45720" tIns="18288" bIns="18288" anchor="ctr">
+            <a:noAutofit/>
+          </a:bodyPr>
+          <a:lstStyle/>
+          <a:p>
+            <a:pPr algn="l"/>
+            <a:r>
+              <a:rPr sz="1989" b="0" i="0">
                 <a:solidFill>
                   <a:srgbClr val="1A1A1A"/>
                 </a:solidFill>
@@ -14779,22 +15343,22 @@
         <p:spPr>
           <a:xfrm>
             <a:off x="777240" y="1463040"/>
-            <a:ext cx="10607040" cy="393589"/>
-          </a:xfrm>
-          <a:prstGeom prst="rect">
-            <a:avLst/>
-          </a:prstGeom>
-          <a:noFill/>
-        </p:spPr>
-        <p:txBody>
-          <a:bodyPr wrap="square" lIns="45720" rIns="45720" tIns="18288" bIns="18288" anchor="t">
-            <a:spAutoFit/>
-          </a:bodyPr>
-          <a:lstStyle/>
-          <a:p>
-            <a:pPr algn="l"/>
-            <a:r>
-              <a:rPr sz="2090" b="1" i="0">
+            <a:ext cx="10607040" cy="357808"/>
+          </a:xfrm>
+          <a:prstGeom prst="rect">
+            <a:avLst/>
+          </a:prstGeom>
+          <a:noFill/>
+        </p:spPr>
+        <p:txBody>
+          <a:bodyPr wrap="square" lIns="45720" rIns="45720" tIns="18288" bIns="18288" anchor="t">
+            <a:spAutoFit/>
+          </a:bodyPr>
+          <a:lstStyle/>
+          <a:p>
+            <a:pPr algn="l"/>
+            <a:r>
+              <a:rPr sz="1900" b="1" i="0">
                 <a:solidFill>
                   <a:srgbClr val="0B5394"/>
                 </a:solidFill>
@@ -14813,23 +15377,23 @@
         </p:nvSpPr>
         <p:spPr>
           <a:xfrm>
-            <a:off x="1143000" y="1856629"/>
-            <a:ext cx="10241280" cy="715617"/>
-          </a:xfrm>
-          <a:prstGeom prst="rect">
-            <a:avLst/>
-          </a:prstGeom>
-          <a:noFill/>
-        </p:spPr>
-        <p:txBody>
-          <a:bodyPr wrap="square" lIns="45720" rIns="45720" tIns="18288" bIns="18288" anchor="t">
-            <a:spAutoFit/>
-          </a:bodyPr>
-          <a:lstStyle/>
-          <a:p>
-            <a:pPr algn="l"/>
-            <a:r>
-              <a:rPr sz="1900" b="0" i="0">
+            <a:off x="1143000" y="1820848"/>
+            <a:ext cx="10241280" cy="644055"/>
+          </a:xfrm>
+          <a:prstGeom prst="rect">
+            <a:avLst/>
+          </a:prstGeom>
+          <a:noFill/>
+        </p:spPr>
+        <p:txBody>
+          <a:bodyPr wrap="square" lIns="45720" rIns="45720" tIns="18288" bIns="18288" anchor="t">
+            <a:spAutoFit/>
+          </a:bodyPr>
+          <a:lstStyle/>
+          <a:p>
+            <a:pPr algn="l"/>
+            <a:r>
+              <a:rPr sz="1710" b="0" i="0">
                 <a:solidFill>
                   <a:srgbClr val="1A1A1A"/>
                 </a:solidFill>
@@ -14848,23 +15412,23 @@
         </p:nvSpPr>
         <p:spPr>
           <a:xfrm>
-            <a:off x="777240" y="2809990"/>
-            <a:ext cx="10607040" cy="393589"/>
-          </a:xfrm>
-          <a:prstGeom prst="rect">
-            <a:avLst/>
-          </a:prstGeom>
-          <a:noFill/>
-        </p:spPr>
-        <p:txBody>
-          <a:bodyPr wrap="square" lIns="45720" rIns="45720" tIns="18288" bIns="18288" anchor="t">
-            <a:spAutoFit/>
-          </a:bodyPr>
-          <a:lstStyle/>
-          <a:p>
-            <a:pPr algn="l"/>
-            <a:r>
-              <a:rPr sz="2090" b="1" i="0">
+            <a:off x="777240" y="2702648"/>
+            <a:ext cx="10607040" cy="357808"/>
+          </a:xfrm>
+          <a:prstGeom prst="rect">
+            <a:avLst/>
+          </a:prstGeom>
+          <a:noFill/>
+        </p:spPr>
+        <p:txBody>
+          <a:bodyPr wrap="square" lIns="45720" rIns="45720" tIns="18288" bIns="18288" anchor="t">
+            <a:spAutoFit/>
+          </a:bodyPr>
+          <a:lstStyle/>
+          <a:p>
+            <a:pPr algn="l"/>
+            <a:r>
+              <a:rPr sz="1900" b="1" i="0">
                 <a:solidFill>
                   <a:srgbClr val="0B5394"/>
                 </a:solidFill>
@@ -14883,8 +15447,8 @@
         </p:nvSpPr>
         <p:spPr>
           <a:xfrm>
-            <a:off x="1143000" y="3180720"/>
-            <a:ext cx="6286288" cy="457200"/>
+            <a:off x="1143000" y="3037597"/>
+            <a:ext cx="5678465" cy="457200"/>
           </a:xfrm>
           <a:prstGeom prst="rect">
             <a:avLst/>
@@ -14899,7 +15463,7 @@
           <a:p>
             <a:pPr algn="l"/>
             <a:r>
-              <a:rPr sz="1900" b="0" i="0">
+              <a:rPr sz="1710" b="0" i="0">
                 <a:solidFill>
                   <a:srgbClr val="1A1A1A"/>
                 </a:solidFill>
@@ -14926,7 +15490,7 @@
         </p:blipFill>
         <p:spPr>
           <a:xfrm>
-            <a:off x="7292128" y="3266064"/>
+            <a:off x="6684305" y="3065410"/>
             <a:ext cx="188976" cy="286512"/>
           </a:xfrm>
           <a:prstGeom prst="rect">
@@ -14942,8 +15506,8 @@
         </p:nvSpPr>
         <p:spPr>
           <a:xfrm>
-            <a:off x="7481104" y="3180720"/>
-            <a:ext cx="2729325" cy="457200"/>
+            <a:off x="6873281" y="3037597"/>
+            <a:ext cx="2477244" cy="457200"/>
           </a:xfrm>
           <a:prstGeom prst="rect">
             <a:avLst/>
@@ -14958,7 +15522,7 @@
           <a:p>
             <a:pPr algn="l"/>
             <a:r>
-              <a:rPr sz="1900" b="0" i="0">
+              <a:rPr sz="1710" b="0" i="0">
                 <a:solidFill>
                   <a:srgbClr val="1A1A1A"/>
                 </a:solidFill>
@@ -14985,7 +15549,7 @@
         </p:blipFill>
         <p:spPr>
           <a:xfrm>
-            <a:off x="10073270" y="3264540"/>
+            <a:off x="9213366" y="3068458"/>
             <a:ext cx="1030224" cy="289560"/>
           </a:xfrm>
           <a:prstGeom prst="rect">
@@ -15001,23 +15565,23 @@
         </p:nvSpPr>
         <p:spPr>
           <a:xfrm>
-            <a:off x="777240" y="3816228"/>
-            <a:ext cx="10607040" cy="393589"/>
-          </a:xfrm>
-          <a:prstGeom prst="rect">
-            <a:avLst/>
-          </a:prstGeom>
-          <a:noFill/>
-        </p:spPr>
-        <p:txBody>
-          <a:bodyPr wrap="square" lIns="45720" rIns="45720" tIns="18288" bIns="18288" anchor="t">
-            <a:spAutoFit/>
-          </a:bodyPr>
-          <a:lstStyle/>
-          <a:p>
-            <a:pPr algn="l"/>
-            <a:r>
-              <a:rPr sz="2090" b="1" i="0">
+            <a:off x="777240" y="3673105"/>
+            <a:ext cx="10607040" cy="357808"/>
+          </a:xfrm>
+          <a:prstGeom prst="rect">
+            <a:avLst/>
+          </a:prstGeom>
+          <a:noFill/>
+        </p:spPr>
+        <p:txBody>
+          <a:bodyPr wrap="square" lIns="45720" rIns="45720" tIns="18288" bIns="18288" anchor="t">
+            <a:spAutoFit/>
+          </a:bodyPr>
+          <a:lstStyle/>
+          <a:p>
+            <a:pPr algn="l"/>
+            <a:r>
+              <a:rPr sz="1900" b="1" i="0">
                 <a:solidFill>
                   <a:srgbClr val="0B5394"/>
                 </a:solidFill>
@@ -15036,23 +15600,23 @@
         </p:nvSpPr>
         <p:spPr>
           <a:xfrm>
-            <a:off x="1143000" y="4209818"/>
-            <a:ext cx="10241280" cy="715617"/>
-          </a:xfrm>
-          <a:prstGeom prst="rect">
-            <a:avLst/>
-          </a:prstGeom>
-          <a:noFill/>
-        </p:spPr>
-        <p:txBody>
-          <a:bodyPr wrap="square" lIns="45720" rIns="45720" tIns="18288" bIns="18288" anchor="t">
-            <a:spAutoFit/>
-          </a:bodyPr>
-          <a:lstStyle/>
-          <a:p>
-            <a:pPr algn="l"/>
-            <a:r>
-              <a:rPr sz="1900" b="0" i="0">
+            <a:off x="1143000" y="4030913"/>
+            <a:ext cx="10241280" cy="644055"/>
+          </a:xfrm>
+          <a:prstGeom prst="rect">
+            <a:avLst/>
+          </a:prstGeom>
+          <a:noFill/>
+        </p:spPr>
+        <p:txBody>
+          <a:bodyPr wrap="square" lIns="45720" rIns="45720" tIns="18288" bIns="18288" anchor="t">
+            <a:spAutoFit/>
+          </a:bodyPr>
+          <a:lstStyle/>
+          <a:p>
+            <a:pPr algn="l"/>
+            <a:r>
+              <a:rPr sz="1710" b="0" i="0">
                 <a:solidFill>
                   <a:srgbClr val="1A1A1A"/>
                 </a:solidFill>
@@ -15071,23 +15635,23 @@
         </p:nvSpPr>
         <p:spPr>
           <a:xfrm>
-            <a:off x="777240" y="5163179"/>
-            <a:ext cx="10607040" cy="393589"/>
-          </a:xfrm>
-          <a:prstGeom prst="rect">
-            <a:avLst/>
-          </a:prstGeom>
-          <a:noFill/>
-        </p:spPr>
-        <p:txBody>
-          <a:bodyPr wrap="square" lIns="45720" rIns="45720" tIns="18288" bIns="18288" anchor="t">
-            <a:spAutoFit/>
-          </a:bodyPr>
-          <a:lstStyle/>
-          <a:p>
-            <a:pPr algn="l"/>
-            <a:r>
-              <a:rPr sz="2090" b="1" i="0">
+            <a:off x="777240" y="4912713"/>
+            <a:ext cx="10607040" cy="357808"/>
+          </a:xfrm>
+          <a:prstGeom prst="rect">
+            <a:avLst/>
+          </a:prstGeom>
+          <a:noFill/>
+        </p:spPr>
+        <p:txBody>
+          <a:bodyPr wrap="square" lIns="45720" rIns="45720" tIns="18288" bIns="18288" anchor="t">
+            <a:spAutoFit/>
+          </a:bodyPr>
+          <a:lstStyle/>
+          <a:p>
+            <a:pPr algn="l"/>
+            <a:r>
+              <a:rPr sz="1900" b="1" i="0">
                 <a:solidFill>
                   <a:srgbClr val="0B5394"/>
                 </a:solidFill>
@@ -15106,29 +15670,88 @@
         </p:nvSpPr>
         <p:spPr>
           <a:xfrm>
-            <a:off x="1143000" y="5556769"/>
-            <a:ext cx="10241280" cy="357808"/>
-          </a:xfrm>
-          <a:prstGeom prst="rect">
-            <a:avLst/>
-          </a:prstGeom>
-          <a:noFill/>
-        </p:spPr>
-        <p:txBody>
-          <a:bodyPr wrap="square" lIns="45720" rIns="45720" tIns="18288" bIns="18288" anchor="t">
-            <a:spAutoFit/>
-          </a:bodyPr>
-          <a:lstStyle/>
-          <a:p>
-            <a:pPr algn="l"/>
-            <a:r>
-              <a:rPr sz="1900" b="0" i="0">
+            <a:off x="1143000" y="5247662"/>
+            <a:ext cx="3553360" cy="457200"/>
+          </a:xfrm>
+          <a:prstGeom prst="rect">
+            <a:avLst/>
+          </a:prstGeom>
+          <a:noFill/>
+        </p:spPr>
+        <p:txBody>
+          <a:bodyPr wrap="none" lIns="45720" rIns="45720" tIns="18288" bIns="18288" anchor="ctr">
+            <a:noAutofit/>
+          </a:bodyPr>
+          <a:lstStyle/>
+          <a:p>
+            <a:pPr algn="l"/>
+            <a:r>
+              <a:rPr sz="1710" b="0" i="0">
                 <a:solidFill>
                   <a:srgbClr val="1A1A1A"/>
                 </a:solidFill>
                 <a:latin typeface="Lexend"/>
               </a:rPr>
-              <a:t>a scale factor with units on it: 1 in : 20 mi means every inch on the map is 20 miles</a:t>
+              <a:t>a scale factor with units on it: </a:t>
+            </a:r>
+          </a:p>
+        </p:txBody>
+      </p:sp>
+      <p:pic>
+        <p:nvPicPr>
+          <p:cNvPr id="19" name="Picture 18" descr="33a234fb1dc3f5cd.png"/>
+          <p:cNvPicPr>
+            <a:picLocks noChangeAspect="1"/>
+          </p:cNvPicPr>
+          <p:nvPr/>
+        </p:nvPicPr>
+        <p:blipFill>
+          <a:blip r:embed="rId4"/>
+          <a:stretch>
+            <a:fillRect/>
+          </a:stretch>
+        </p:blipFill>
+        <p:spPr>
+          <a:xfrm>
+            <a:off x="4559200" y="5270522"/>
+            <a:ext cx="1728216" cy="301752"/>
+          </a:xfrm>
+          <a:prstGeom prst="rect">
+            <a:avLst/>
+          </a:prstGeom>
+        </p:spPr>
+      </p:pic>
+      <p:sp>
+        <p:nvSpPr>
+          <p:cNvPr id="20" name="TextBox 19"/>
+          <p:cNvSpPr txBox="1"/>
+          <p:nvPr/>
+        </p:nvSpPr>
+        <p:spPr>
+          <a:xfrm>
+            <a:off x="6287416" y="5247662"/>
+            <a:ext cx="4772252" cy="457200"/>
+          </a:xfrm>
+          <a:prstGeom prst="rect">
+            <a:avLst/>
+          </a:prstGeom>
+          <a:noFill/>
+        </p:spPr>
+        <p:txBody>
+          <a:bodyPr wrap="none" lIns="45720" rIns="45720" tIns="18288" bIns="18288" anchor="ctr">
+            <a:noAutofit/>
+          </a:bodyPr>
+          <a:lstStyle/>
+          <a:p>
+            <a:pPr algn="l"/>
+            <a:r>
+              <a:rPr sz="1710" b="0" i="0">
+                <a:solidFill>
+                  <a:srgbClr val="1A1A1A"/>
+                </a:solidFill>
+                <a:latin typeface="Lexend"/>
+              </a:rPr>
+              <a:t> means every inch on the map is 20 miles</a:t>
             </a:r>
           </a:p>
         </p:txBody>
@@ -16185,7 +16808,7 @@
         </p:blipFill>
         <p:spPr>
           <a:xfrm>
-            <a:off x="2462784" y="2005584"/>
+            <a:off x="2462784" y="2017776"/>
             <a:ext cx="7235952" cy="387096"/>
           </a:xfrm>
           <a:prstGeom prst="rect">
@@ -16209,7 +16832,7 @@
         </p:blipFill>
         <p:spPr>
           <a:xfrm>
-            <a:off x="1667255" y="2734056"/>
+            <a:off x="1667255" y="2713101"/>
             <a:ext cx="8827008" cy="301752"/>
           </a:xfrm>
           <a:prstGeom prst="rect">

</xml_diff>

<commit_message>
A7 Unit 5 rebuilt: inline mathematics at the words' size on every slide (kit vendored); 0 findings, installed
Co-Authored-By: Claude Fable 5.1 <noreply@anthropic.com>
Claude-Session: https://claude.ai/code/session_01B7ovt6yLjh6QuFV9HBMV4N
</commit_message>
<xml_diff>
--- a/a7/build/out/u5/A7 5.01 Scale Drawings - Slides.pptx
+++ b/a7/build/out/u5/A7 5.01 Scale Drawings - Slides.pptx
@@ -4049,7 +4049,7 @@
         </p:blipFill>
         <p:spPr>
           <a:xfrm>
-            <a:off x="4253298" y="2751548"/>
+            <a:off x="4204312" y="2751548"/>
             <a:ext cx="1673352" cy="603504"/>
           </a:xfrm>
           <a:prstGeom prst="rect">
@@ -4059,7 +4059,7 @@
       </p:pic>
       <p:pic>
         <p:nvPicPr>
-          <p:cNvPr id="11" name="Picture 10" descr="ea6090423d2d6b79.png"/>
+          <p:cNvPr id="11" name="Picture 10" descr="c01a75d5d6aaea9f.png"/>
           <p:cNvPicPr>
             <a:picLocks noChangeAspect="1"/>
           </p:cNvPicPr>
@@ -4073,8 +4073,8 @@
         </p:blipFill>
         <p:spPr>
           <a:xfrm>
-            <a:off x="4253298" y="3483068"/>
-            <a:ext cx="1194816" cy="612648"/>
+            <a:off x="4204312" y="3483068"/>
+            <a:ext cx="1292733" cy="664321"/>
           </a:xfrm>
           <a:prstGeom prst="rect">
             <a:avLst/>
@@ -4089,7 +4089,7 @@
         </p:nvSpPr>
         <p:spPr>
           <a:xfrm>
-            <a:off x="5448114" y="3560792"/>
+            <a:off x="5497045" y="3586629"/>
             <a:ext cx="2710042" cy="457200"/>
           </a:xfrm>
           <a:prstGeom prst="rect">
@@ -4387,7 +4387,7 @@
         </p:nvSpPr>
         <p:spPr>
           <a:xfrm>
-            <a:off x="4060700" y="1714500"/>
+            <a:off x="4061271" y="1714500"/>
             <a:ext cx="2641202" cy="457200"/>
           </a:xfrm>
           <a:prstGeom prst="rect">
@@ -4416,7 +4416,7 @@
       </p:sp>
       <p:pic>
         <p:nvPicPr>
-          <p:cNvPr id="9" name="Picture 8" descr="d7f44fc30d54f3bb.png"/>
+          <p:cNvPr id="9" name="Picture 8" descr="46801c56b80b5c76.png"/>
           <p:cNvPicPr>
             <a:picLocks noChangeAspect="1"/>
           </p:cNvPicPr>
@@ -4430,8 +4430,8 @@
         </p:blipFill>
         <p:spPr>
           <a:xfrm>
-            <a:off x="6564742" y="1819656"/>
-            <a:ext cx="1392936" cy="243840"/>
+            <a:off x="6565313" y="1817179"/>
+            <a:ext cx="1391793" cy="245173"/>
           </a:xfrm>
           <a:prstGeom prst="rect">
             <a:avLst/>
@@ -4446,7 +4446,7 @@
         </p:nvSpPr>
         <p:spPr>
           <a:xfrm>
-            <a:off x="7957678" y="1714500"/>
+            <a:off x="7957106" y="1714500"/>
             <a:ext cx="280301" cy="457200"/>
           </a:xfrm>
           <a:prstGeom prst="rect">
@@ -5066,7 +5066,7 @@
         </p:nvSpPr>
         <p:spPr>
           <a:xfrm>
-            <a:off x="3931160" y="1577340"/>
+            <a:off x="3931255" y="1577340"/>
             <a:ext cx="2641202" cy="457200"/>
           </a:xfrm>
           <a:prstGeom prst="rect">
@@ -5095,7 +5095,7 @@
       </p:sp>
       <p:pic>
         <p:nvPicPr>
-          <p:cNvPr id="9" name="Picture 8" descr="06167158fe892fe2.png"/>
+          <p:cNvPr id="9" name="Picture 8" descr="e81d11d57c22f065.png"/>
           <p:cNvPicPr>
             <a:picLocks noChangeAspect="1"/>
           </p:cNvPicPr>
@@ -5109,8 +5109,8 @@
         </p:blipFill>
         <p:spPr>
           <a:xfrm>
-            <a:off x="6435202" y="1691640"/>
-            <a:ext cx="1652016" cy="234696"/>
+            <a:off x="6435297" y="1689925"/>
+            <a:ext cx="1651825" cy="235267"/>
           </a:xfrm>
           <a:prstGeom prst="rect">
             <a:avLst/>
@@ -5125,7 +5125,7 @@
         </p:nvSpPr>
         <p:spPr>
           <a:xfrm>
-            <a:off x="8087218" y="1577340"/>
+            <a:off x="8087123" y="1577340"/>
             <a:ext cx="280301" cy="457200"/>
           </a:xfrm>
           <a:prstGeom prst="rect">
@@ -5458,7 +5458,7 @@
         </p:nvSpPr>
         <p:spPr>
           <a:xfrm>
-            <a:off x="3931160" y="1577340"/>
+            <a:off x="3931255" y="1577340"/>
             <a:ext cx="2641202" cy="457200"/>
           </a:xfrm>
           <a:prstGeom prst="rect">
@@ -5487,7 +5487,7 @@
       </p:sp>
       <p:pic>
         <p:nvPicPr>
-          <p:cNvPr id="9" name="Picture 8" descr="e2bec98e965b49e0.png"/>
+          <p:cNvPr id="9" name="Picture 8" descr="9dc5c0b3d418a1a5.png"/>
           <p:cNvPicPr>
             <a:picLocks noChangeAspect="1"/>
           </p:cNvPicPr>
@@ -5501,8 +5501,8 @@
         </p:blipFill>
         <p:spPr>
           <a:xfrm>
-            <a:off x="6435202" y="1691640"/>
-            <a:ext cx="1652016" cy="234696"/>
+            <a:off x="6435297" y="1689925"/>
+            <a:ext cx="1651825" cy="235267"/>
           </a:xfrm>
           <a:prstGeom prst="rect">
             <a:avLst/>
@@ -5517,7 +5517,7 @@
         </p:nvSpPr>
         <p:spPr>
           <a:xfrm>
-            <a:off x="8087218" y="1577340"/>
+            <a:off x="8087123" y="1577340"/>
             <a:ext cx="280301" cy="457200"/>
           </a:xfrm>
           <a:prstGeom prst="rect">
@@ -7318,7 +7318,7 @@
       </p:sp>
       <p:pic>
         <p:nvPicPr>
-          <p:cNvPr id="9" name="Picture 8" descr="c477c7b8f5111bdc.png"/>
+          <p:cNvPr id="9" name="Picture 8" descr="c053a830935dbdf4.png"/>
           <p:cNvPicPr>
             <a:picLocks noChangeAspect="1"/>
           </p:cNvPicPr>
@@ -7332,8 +7332,8 @@
         </p:blipFill>
         <p:spPr>
           <a:xfrm>
-            <a:off x="4659168" y="1555813"/>
-            <a:ext cx="1493520" cy="283464"/>
+            <a:off x="4659168" y="1564719"/>
+            <a:ext cx="1433480" cy="270557"/>
           </a:xfrm>
           <a:prstGeom prst="rect">
             <a:avLst/>
@@ -7377,7 +7377,7 @@
       </p:sp>
       <p:pic>
         <p:nvPicPr>
-          <p:cNvPr id="11" name="Picture 10" descr="bdfad0a4d6a24e79.png"/>
+          <p:cNvPr id="11" name="Picture 10" descr="f504cbed100f80e6.png"/>
           <p:cNvPicPr>
             <a:picLocks noChangeAspect="1"/>
           </p:cNvPicPr>
@@ -7391,8 +7391,8 @@
         </p:blipFill>
         <p:spPr>
           <a:xfrm>
-            <a:off x="4673306" y="2083117"/>
-            <a:ext cx="679704" cy="390144"/>
+            <a:off x="4673306" y="2096674"/>
+            <a:ext cx="647914" cy="372610"/>
           </a:xfrm>
           <a:prstGeom prst="rect">
             <a:avLst/>
@@ -7436,7 +7436,7 @@
       </p:sp>
       <p:pic>
         <p:nvPicPr>
-          <p:cNvPr id="13" name="Picture 12" descr="df9e392240993d60.png"/>
+          <p:cNvPr id="13" name="Picture 12" descr="3826b61b6c6b81ae.png"/>
           <p:cNvPicPr>
             <a:picLocks noChangeAspect="1"/>
           </p:cNvPicPr>
@@ -7450,8 +7450,8 @@
         </p:blipFill>
         <p:spPr>
           <a:xfrm>
-            <a:off x="3358447" y="2738437"/>
-            <a:ext cx="1130808" cy="271272"/>
+            <a:off x="3358447" y="2744922"/>
+            <a:ext cx="1084603" cy="263437"/>
           </a:xfrm>
           <a:prstGeom prst="rect">
             <a:avLst/>
@@ -7466,7 +7466,7 @@
         </p:nvSpPr>
         <p:spPr>
           <a:xfrm>
-            <a:off x="4489255" y="2665476"/>
+            <a:off x="4443051" y="2665476"/>
             <a:ext cx="2186646" cy="457200"/>
           </a:xfrm>
           <a:prstGeom prst="rect">
@@ -10099,7 +10099,7 @@
       </p:sp>
       <p:pic>
         <p:nvPicPr>
-          <p:cNvPr id="9" name="Picture 8" descr="fc22e08664d80881.png"/>
+          <p:cNvPr id="9" name="Picture 8" descr="6f3278420c632641.png"/>
           <p:cNvPicPr>
             <a:picLocks noChangeAspect="1"/>
           </p:cNvPicPr>
@@ -10113,8 +10113,8 @@
         </p:blipFill>
         <p:spPr>
           <a:xfrm>
-            <a:off x="10309628" y="1965960"/>
-            <a:ext cx="853440" cy="234696"/>
+            <a:off x="10309628" y="1964245"/>
+            <a:ext cx="851916" cy="235267"/>
           </a:xfrm>
           <a:prstGeom prst="rect">
             <a:avLst/>
@@ -10129,7 +10129,7 @@
         </p:nvSpPr>
         <p:spPr>
           <a:xfrm>
-            <a:off x="11163068" y="1851660"/>
+            <a:off x="11161544" y="1851660"/>
             <a:ext cx="280301" cy="457200"/>
           </a:xfrm>
           <a:prstGeom prst="rect">
@@ -10727,7 +10727,7 @@
       </p:sp>
       <p:pic>
         <p:nvPicPr>
-          <p:cNvPr id="9" name="Picture 8" descr="39705602679ca241.png"/>
+          <p:cNvPr id="9" name="Picture 8" descr="0faca9856b4fca4c.png"/>
           <p:cNvPicPr>
             <a:picLocks noChangeAspect="1"/>
           </p:cNvPicPr>
@@ -10741,8 +10741,8 @@
         </p:blipFill>
         <p:spPr>
           <a:xfrm>
-            <a:off x="10309628" y="1965960"/>
-            <a:ext cx="853440" cy="234696"/>
+            <a:off x="10309628" y="1964245"/>
+            <a:ext cx="854392" cy="235267"/>
           </a:xfrm>
           <a:prstGeom prst="rect">
             <a:avLst/>
@@ -10757,7 +10757,7 @@
         </p:nvSpPr>
         <p:spPr>
           <a:xfrm>
-            <a:off x="11163068" y="1851660"/>
+            <a:off x="11164021" y="1851660"/>
             <a:ext cx="280301" cy="457200"/>
           </a:xfrm>
           <a:prstGeom prst="rect">
@@ -11546,7 +11546,7 @@
       </p:sp>
       <p:pic>
         <p:nvPicPr>
-          <p:cNvPr id="10" name="Picture 9" descr="1caa99a087a8b73f.png"/>
+          <p:cNvPr id="10" name="Picture 9" descr="3af538f0ea090d26.png"/>
           <p:cNvPicPr>
             <a:picLocks noChangeAspect="1"/>
           </p:cNvPicPr>
@@ -11560,8 +11560,8 @@
         </p:blipFill>
         <p:spPr>
           <a:xfrm>
-            <a:off x="2929559" y="3500959"/>
-            <a:ext cx="2496312" cy="612648"/>
+            <a:off x="2825106" y="3500959"/>
+            <a:ext cx="2705163" cy="664321"/>
           </a:xfrm>
           <a:prstGeom prst="rect">
             <a:avLst/>
@@ -11576,7 +11576,7 @@
         </p:nvSpPr>
         <p:spPr>
           <a:xfrm>
-            <a:off x="5425871" y="3578683"/>
+            <a:off x="5530269" y="3604519"/>
             <a:ext cx="4056024" cy="457200"/>
           </a:xfrm>
           <a:prstGeom prst="rect">
@@ -11605,7 +11605,7 @@
       </p:sp>
       <p:pic>
         <p:nvPicPr>
-          <p:cNvPr id="12" name="Picture 11" descr="66f8f0a44e616783.png"/>
+          <p:cNvPr id="12" name="Picture 11" descr="102070a7c64f056e.png"/>
           <p:cNvPicPr>
             <a:picLocks noChangeAspect="1"/>
           </p:cNvPicPr>
@@ -11619,8 +11619,8 @@
         </p:blipFill>
         <p:spPr>
           <a:xfrm>
-            <a:off x="2929559" y="4241623"/>
-            <a:ext cx="1996439" cy="609600"/>
+            <a:off x="2825106" y="4293296"/>
+            <a:ext cx="2163532" cy="661328"/>
           </a:xfrm>
           <a:prstGeom prst="rect">
             <a:avLst/>
@@ -11635,7 +11635,7 @@
         </p:nvSpPr>
         <p:spPr>
           <a:xfrm>
-            <a:off x="4925999" y="4317823"/>
+            <a:off x="4988638" y="4395360"/>
             <a:ext cx="3005336" cy="457200"/>
           </a:xfrm>
           <a:prstGeom prst="rect">
@@ -11670,7 +11670,7 @@
         </p:nvSpPr>
         <p:spPr>
           <a:xfrm>
-            <a:off x="777240" y="4988383"/>
+            <a:off x="777240" y="5091785"/>
             <a:ext cx="10607040" cy="1072896"/>
           </a:xfrm>
           <a:prstGeom prst="rect">
@@ -11962,7 +11962,7 @@
       </p:sp>
       <p:pic>
         <p:nvPicPr>
-          <p:cNvPr id="9" name="Picture 8" descr="c477c7b8f5111bdc.png"/>
+          <p:cNvPr id="9" name="Picture 8" descr="c053a830935dbdf4.png"/>
           <p:cNvPicPr>
             <a:picLocks noChangeAspect="1"/>
           </p:cNvPicPr>
@@ -11976,8 +11976,8 @@
         </p:blipFill>
         <p:spPr>
           <a:xfrm>
-            <a:off x="4659168" y="1555813"/>
-            <a:ext cx="1493520" cy="283464"/>
+            <a:off x="4659168" y="1564719"/>
+            <a:ext cx="1433480" cy="270557"/>
           </a:xfrm>
           <a:prstGeom prst="rect">
             <a:avLst/>
@@ -11992,7 +11992,7 @@
         </p:nvSpPr>
         <p:spPr>
           <a:xfrm>
-            <a:off x="6701328" y="1440180"/>
+            <a:off x="6641289" y="1440180"/>
             <a:ext cx="556211" cy="457200"/>
           </a:xfrm>
           <a:prstGeom prst="rect">
@@ -12056,7 +12056,7 @@
       </p:sp>
       <p:pic>
         <p:nvPicPr>
-          <p:cNvPr id="12" name="Picture 11" descr="bdfad0a4d6a24e79.png"/>
+          <p:cNvPr id="12" name="Picture 11" descr="f504cbed100f80e6.png"/>
           <p:cNvPicPr>
             <a:picLocks noChangeAspect="1"/>
           </p:cNvPicPr>
@@ -12070,8 +12070,8 @@
         </p:blipFill>
         <p:spPr>
           <a:xfrm>
-            <a:off x="4673306" y="2083117"/>
-            <a:ext cx="679704" cy="390144"/>
+            <a:off x="4673306" y="2096674"/>
+            <a:ext cx="647914" cy="372610"/>
           </a:xfrm>
           <a:prstGeom prst="rect">
             <a:avLst/>
@@ -12086,7 +12086,7 @@
         </p:nvSpPr>
         <p:spPr>
           <a:xfrm>
-            <a:off x="5901650" y="2052828"/>
+            <a:off x="5869860" y="2052828"/>
             <a:ext cx="380014" cy="457200"/>
           </a:xfrm>
           <a:prstGeom prst="rect">
@@ -12150,7 +12150,7 @@
       </p:sp>
       <p:pic>
         <p:nvPicPr>
-          <p:cNvPr id="15" name="Picture 14" descr="df9e392240993d60.png"/>
+          <p:cNvPr id="15" name="Picture 14" descr="3826b61b6c6b81ae.png"/>
           <p:cNvPicPr>
             <a:picLocks noChangeAspect="1"/>
           </p:cNvPicPr>
@@ -12164,8 +12164,8 @@
         </p:blipFill>
         <p:spPr>
           <a:xfrm>
-            <a:off x="3358447" y="2738437"/>
-            <a:ext cx="1130808" cy="271272"/>
+            <a:off x="3358447" y="2744922"/>
+            <a:ext cx="1084603" cy="263437"/>
           </a:xfrm>
           <a:prstGeom prst="rect">
             <a:avLst/>
@@ -12180,7 +12180,7 @@
         </p:nvSpPr>
         <p:spPr>
           <a:xfrm>
-            <a:off x="4489255" y="2665476"/>
+            <a:off x="4443051" y="2665476"/>
             <a:ext cx="2186646" cy="457200"/>
           </a:xfrm>
           <a:prstGeom prst="rect">
@@ -12215,7 +12215,7 @@
         </p:nvSpPr>
         <p:spPr>
           <a:xfrm>
-            <a:off x="7087382" y="2665476"/>
+            <a:off x="7041178" y="2665476"/>
             <a:ext cx="1028302" cy="457200"/>
           </a:xfrm>
           <a:prstGeom prst="rect">
@@ -12945,7 +12945,7 @@
       </p:sp>
       <p:pic>
         <p:nvPicPr>
-          <p:cNvPr id="10" name="Picture 9" descr="53b8b83f65f5ccbf.png"/>
+          <p:cNvPr id="10" name="Picture 9" descr="4238e14711500235.png"/>
           <p:cNvPicPr>
             <a:picLocks noChangeAspect="1"/>
           </p:cNvPicPr>
@@ -12959,8 +12959,8 @@
         </p:blipFill>
         <p:spPr>
           <a:xfrm>
-            <a:off x="3846582" y="3168553"/>
-            <a:ext cx="1374648" cy="252984"/>
+            <a:off x="3791781" y="3149114"/>
+            <a:ext cx="1487241" cy="272311"/>
           </a:xfrm>
           <a:prstGeom prst="rect">
             <a:avLst/>
@@ -12975,7 +12975,7 @@
         </p:nvSpPr>
         <p:spPr>
           <a:xfrm>
-            <a:off x="5221230" y="3048728"/>
+            <a:off x="5279023" y="3048728"/>
             <a:ext cx="3340595" cy="457200"/>
           </a:xfrm>
           <a:prstGeom prst="rect">
@@ -13018,7 +13018,7 @@
         </p:blipFill>
         <p:spPr>
           <a:xfrm>
-            <a:off x="3846582" y="3708049"/>
+            <a:off x="3791781" y="3708049"/>
             <a:ext cx="1453896" cy="252984"/>
           </a:xfrm>
           <a:prstGeom prst="rect">
@@ -13694,7 +13694,7 @@
       </p:sp>
       <p:pic>
         <p:nvPicPr>
-          <p:cNvPr id="10" name="Picture 9" descr="0673d22e8596ca7b.png"/>
+          <p:cNvPr id="10" name="Picture 9" descr="50c40483c37e069c.png"/>
           <p:cNvPicPr>
             <a:picLocks noChangeAspect="1"/>
           </p:cNvPicPr>
@@ -13708,8 +13708,8 @@
         </p:blipFill>
         <p:spPr>
           <a:xfrm>
-            <a:off x="2587682" y="3071588"/>
-            <a:ext cx="1063752" cy="512064"/>
+            <a:off x="2543413" y="3071588"/>
+            <a:ext cx="1150282" cy="556180"/>
           </a:xfrm>
           <a:prstGeom prst="rect">
             <a:avLst/>
@@ -13724,7 +13724,7 @@
         </p:nvSpPr>
         <p:spPr>
           <a:xfrm>
-            <a:off x="3651434" y="3099020"/>
+            <a:off x="3693695" y="3121079"/>
             <a:ext cx="6166242" cy="457200"/>
           </a:xfrm>
           <a:prstGeom prst="rect">
@@ -15343,22 +15343,22 @@
         <p:spPr>
           <a:xfrm>
             <a:off x="777240" y="1463040"/>
-            <a:ext cx="10607040" cy="357808"/>
-          </a:xfrm>
-          <a:prstGeom prst="rect">
-            <a:avLst/>
-          </a:prstGeom>
-          <a:noFill/>
-        </p:spPr>
-        <p:txBody>
-          <a:bodyPr wrap="square" lIns="45720" rIns="45720" tIns="18288" bIns="18288" anchor="t">
-            <a:spAutoFit/>
-          </a:bodyPr>
-          <a:lstStyle/>
-          <a:p>
-            <a:pPr algn="l"/>
-            <a:r>
-              <a:rPr sz="1900" b="1" i="0">
+            <a:ext cx="10607040" cy="393589"/>
+          </a:xfrm>
+          <a:prstGeom prst="rect">
+            <a:avLst/>
+          </a:prstGeom>
+          <a:noFill/>
+        </p:spPr>
+        <p:txBody>
+          <a:bodyPr wrap="square" lIns="45720" rIns="45720" tIns="18288" bIns="18288" anchor="t">
+            <a:spAutoFit/>
+          </a:bodyPr>
+          <a:lstStyle/>
+          <a:p>
+            <a:pPr algn="l"/>
+            <a:r>
+              <a:rPr sz="2090" b="1" i="0">
                 <a:solidFill>
                   <a:srgbClr val="0B5394"/>
                 </a:solidFill>
@@ -15377,23 +15377,23 @@
         </p:nvSpPr>
         <p:spPr>
           <a:xfrm>
-            <a:off x="1143000" y="1820848"/>
-            <a:ext cx="10241280" cy="644055"/>
-          </a:xfrm>
-          <a:prstGeom prst="rect">
-            <a:avLst/>
-          </a:prstGeom>
-          <a:noFill/>
-        </p:spPr>
-        <p:txBody>
-          <a:bodyPr wrap="square" lIns="45720" rIns="45720" tIns="18288" bIns="18288" anchor="t">
-            <a:spAutoFit/>
-          </a:bodyPr>
-          <a:lstStyle/>
-          <a:p>
-            <a:pPr algn="l"/>
-            <a:r>
-              <a:rPr sz="1710" b="0" i="0">
+            <a:off x="1143000" y="1856629"/>
+            <a:ext cx="10241280" cy="715617"/>
+          </a:xfrm>
+          <a:prstGeom prst="rect">
+            <a:avLst/>
+          </a:prstGeom>
+          <a:noFill/>
+        </p:spPr>
+        <p:txBody>
+          <a:bodyPr wrap="square" lIns="45720" rIns="45720" tIns="18288" bIns="18288" anchor="t">
+            <a:spAutoFit/>
+          </a:bodyPr>
+          <a:lstStyle/>
+          <a:p>
+            <a:pPr algn="l"/>
+            <a:r>
+              <a:rPr sz="1900" b="0" i="0">
                 <a:solidFill>
                   <a:srgbClr val="1A1A1A"/>
                 </a:solidFill>
@@ -15412,23 +15412,23 @@
         </p:nvSpPr>
         <p:spPr>
           <a:xfrm>
-            <a:off x="777240" y="2702648"/>
-            <a:ext cx="10607040" cy="357808"/>
-          </a:xfrm>
-          <a:prstGeom prst="rect">
-            <a:avLst/>
-          </a:prstGeom>
-          <a:noFill/>
-        </p:spPr>
-        <p:txBody>
-          <a:bodyPr wrap="square" lIns="45720" rIns="45720" tIns="18288" bIns="18288" anchor="t">
-            <a:spAutoFit/>
-          </a:bodyPr>
-          <a:lstStyle/>
-          <a:p>
-            <a:pPr algn="l"/>
-            <a:r>
-              <a:rPr sz="1900" b="1" i="0">
+            <a:off x="777240" y="2809990"/>
+            <a:ext cx="10607040" cy="393589"/>
+          </a:xfrm>
+          <a:prstGeom prst="rect">
+            <a:avLst/>
+          </a:prstGeom>
+          <a:noFill/>
+        </p:spPr>
+        <p:txBody>
+          <a:bodyPr wrap="square" lIns="45720" rIns="45720" tIns="18288" bIns="18288" anchor="t">
+            <a:spAutoFit/>
+          </a:bodyPr>
+          <a:lstStyle/>
+          <a:p>
+            <a:pPr algn="l"/>
+            <a:r>
+              <a:rPr sz="2090" b="1" i="0">
                 <a:solidFill>
                   <a:srgbClr val="0B5394"/>
                 </a:solidFill>
@@ -15447,8 +15447,8 @@
         </p:nvSpPr>
         <p:spPr>
           <a:xfrm>
-            <a:off x="1143000" y="3037597"/>
-            <a:ext cx="5678465" cy="457200"/>
+            <a:off x="1143000" y="3180720"/>
+            <a:ext cx="6286288" cy="457200"/>
           </a:xfrm>
           <a:prstGeom prst="rect">
             <a:avLst/>
@@ -15463,7 +15463,7 @@
           <a:p>
             <a:pPr algn="l"/>
             <a:r>
-              <a:rPr sz="1710" b="0" i="0">
+              <a:rPr sz="1900" b="0" i="0">
                 <a:solidFill>
                   <a:srgbClr val="1A1A1A"/>
                 </a:solidFill>
@@ -15490,8 +15490,8 @@
         </p:blipFill>
         <p:spPr>
           <a:xfrm>
-            <a:off x="6684305" y="3065410"/>
-            <a:ext cx="188976" cy="286512"/>
+            <a:off x="7292128" y="3310578"/>
+            <a:ext cx="127952" cy="193992"/>
           </a:xfrm>
           <a:prstGeom prst="rect">
             <a:avLst/>
@@ -15506,8 +15506,8 @@
         </p:nvSpPr>
         <p:spPr>
           <a:xfrm>
-            <a:off x="6873281" y="3037597"/>
-            <a:ext cx="2477244" cy="457200"/>
+            <a:off x="7420080" y="3180720"/>
+            <a:ext cx="2729325" cy="457200"/>
           </a:xfrm>
           <a:prstGeom prst="rect">
             <a:avLst/>
@@ -15522,7 +15522,7 @@
           <a:p>
             <a:pPr algn="l"/>
             <a:r>
-              <a:rPr sz="1710" b="0" i="0">
+              <a:rPr sz="1900" b="0" i="0">
                 <a:solidFill>
                   <a:srgbClr val="1A1A1A"/>
                 </a:solidFill>
@@ -15549,8 +15549,8 @@
         </p:blipFill>
         <p:spPr>
           <a:xfrm>
-            <a:off x="9213366" y="3068458"/>
-            <a:ext cx="1030224" cy="289560"/>
+            <a:off x="10012246" y="3312641"/>
+            <a:ext cx="697547" cy="196056"/>
           </a:xfrm>
           <a:prstGeom prst="rect">
             <a:avLst/>
@@ -15565,23 +15565,23 @@
         </p:nvSpPr>
         <p:spPr>
           <a:xfrm>
-            <a:off x="777240" y="3673105"/>
-            <a:ext cx="10607040" cy="357808"/>
-          </a:xfrm>
-          <a:prstGeom prst="rect">
-            <a:avLst/>
-          </a:prstGeom>
-          <a:noFill/>
-        </p:spPr>
-        <p:txBody>
-          <a:bodyPr wrap="square" lIns="45720" rIns="45720" tIns="18288" bIns="18288" anchor="t">
-            <a:spAutoFit/>
-          </a:bodyPr>
-          <a:lstStyle/>
-          <a:p>
-            <a:pPr algn="l"/>
-            <a:r>
-              <a:rPr sz="1900" b="1" i="0">
+            <a:off x="777240" y="3816228"/>
+            <a:ext cx="10607040" cy="393589"/>
+          </a:xfrm>
+          <a:prstGeom prst="rect">
+            <a:avLst/>
+          </a:prstGeom>
+          <a:noFill/>
+        </p:spPr>
+        <p:txBody>
+          <a:bodyPr wrap="square" lIns="45720" rIns="45720" tIns="18288" bIns="18288" anchor="t">
+            <a:spAutoFit/>
+          </a:bodyPr>
+          <a:lstStyle/>
+          <a:p>
+            <a:pPr algn="l"/>
+            <a:r>
+              <a:rPr sz="2090" b="1" i="0">
                 <a:solidFill>
                   <a:srgbClr val="0B5394"/>
                 </a:solidFill>
@@ -15600,23 +15600,23 @@
         </p:nvSpPr>
         <p:spPr>
           <a:xfrm>
-            <a:off x="1143000" y="4030913"/>
-            <a:ext cx="10241280" cy="644055"/>
-          </a:xfrm>
-          <a:prstGeom prst="rect">
-            <a:avLst/>
-          </a:prstGeom>
-          <a:noFill/>
-        </p:spPr>
-        <p:txBody>
-          <a:bodyPr wrap="square" lIns="45720" rIns="45720" tIns="18288" bIns="18288" anchor="t">
-            <a:spAutoFit/>
-          </a:bodyPr>
-          <a:lstStyle/>
-          <a:p>
-            <a:pPr algn="l"/>
-            <a:r>
-              <a:rPr sz="1710" b="0" i="0">
+            <a:off x="1143000" y="4209818"/>
+            <a:ext cx="10241280" cy="715617"/>
+          </a:xfrm>
+          <a:prstGeom prst="rect">
+            <a:avLst/>
+          </a:prstGeom>
+          <a:noFill/>
+        </p:spPr>
+        <p:txBody>
+          <a:bodyPr wrap="square" lIns="45720" rIns="45720" tIns="18288" bIns="18288" anchor="t">
+            <a:spAutoFit/>
+          </a:bodyPr>
+          <a:lstStyle/>
+          <a:p>
+            <a:pPr algn="l"/>
+            <a:r>
+              <a:rPr sz="1900" b="0" i="0">
                 <a:solidFill>
                   <a:srgbClr val="1A1A1A"/>
                 </a:solidFill>
@@ -15635,23 +15635,23 @@
         </p:nvSpPr>
         <p:spPr>
           <a:xfrm>
-            <a:off x="777240" y="4912713"/>
-            <a:ext cx="10607040" cy="357808"/>
-          </a:xfrm>
-          <a:prstGeom prst="rect">
-            <a:avLst/>
-          </a:prstGeom>
-          <a:noFill/>
-        </p:spPr>
-        <p:txBody>
-          <a:bodyPr wrap="square" lIns="45720" rIns="45720" tIns="18288" bIns="18288" anchor="t">
-            <a:spAutoFit/>
-          </a:bodyPr>
-          <a:lstStyle/>
-          <a:p>
-            <a:pPr algn="l"/>
-            <a:r>
-              <a:rPr sz="1900" b="1" i="0">
+            <a:off x="777240" y="5163179"/>
+            <a:ext cx="10607040" cy="393589"/>
+          </a:xfrm>
+          <a:prstGeom prst="rect">
+            <a:avLst/>
+          </a:prstGeom>
+          <a:noFill/>
+        </p:spPr>
+        <p:txBody>
+          <a:bodyPr wrap="square" lIns="45720" rIns="45720" tIns="18288" bIns="18288" anchor="t">
+            <a:spAutoFit/>
+          </a:bodyPr>
+          <a:lstStyle/>
+          <a:p>
+            <a:pPr algn="l"/>
+            <a:r>
+              <a:rPr sz="2090" b="1" i="0">
                 <a:solidFill>
                   <a:srgbClr val="0B5394"/>
                 </a:solidFill>
@@ -15670,8 +15670,8 @@
         </p:nvSpPr>
         <p:spPr>
           <a:xfrm>
-            <a:off x="1143000" y="5247662"/>
-            <a:ext cx="3553360" cy="457200"/>
+            <a:off x="1143000" y="5533909"/>
+            <a:ext cx="3924887" cy="457200"/>
           </a:xfrm>
           <a:prstGeom prst="rect">
             <a:avLst/>
@@ -15686,7 +15686,7 @@
           <a:p>
             <a:pPr algn="l"/>
             <a:r>
-              <a:rPr sz="1710" b="0" i="0">
+              <a:rPr sz="1900" b="0" i="0">
                 <a:solidFill>
                   <a:srgbClr val="1A1A1A"/>
                 </a:solidFill>
@@ -15713,8 +15713,8 @@
         </p:blipFill>
         <p:spPr>
           <a:xfrm>
-            <a:off x="4559200" y="5270522"/>
-            <a:ext cx="1728216" cy="301752"/>
+            <a:off x="4930727" y="5657575"/>
+            <a:ext cx="1170146" cy="204311"/>
           </a:xfrm>
           <a:prstGeom prst="rect">
             <a:avLst/>
@@ -15729,8 +15729,8 @@
         </p:nvSpPr>
         <p:spPr>
           <a:xfrm>
-            <a:off x="6287416" y="5247662"/>
-            <a:ext cx="4772252" cy="457200"/>
+            <a:off x="6100874" y="5533909"/>
+            <a:ext cx="5279312" cy="457200"/>
           </a:xfrm>
           <a:prstGeom prst="rect">
             <a:avLst/>
@@ -15745,7 +15745,7 @@
           <a:p>
             <a:pPr algn="l"/>
             <a:r>
-              <a:rPr sz="1710" b="0" i="0">
+              <a:rPr sz="1900" b="0" i="0">
                 <a:solidFill>
                   <a:srgbClr val="1A1A1A"/>
                 </a:solidFill>

</xml_diff>

<commit_message>
A7 Unit 5 rebuilt on the capped inline-math kit; 0 findings, installed
Co-Authored-By: Claude Fable 5.1 <noreply@anthropic.com>
Claude-Session: https://claude.ai/code/session_01B7ovt6yLjh6QuFV9HBMV4N
</commit_message>
<xml_diff>
--- a/a7/build/out/u5/A7 5.01 Scale Drawings - Slides.pptx
+++ b/a7/build/out/u5/A7 5.01 Scale Drawings - Slides.pptx
@@ -4049,7 +4049,7 @@
         </p:blipFill>
         <p:spPr>
           <a:xfrm>
-            <a:off x="4204312" y="2751548"/>
+            <a:off x="4253917" y="2751548"/>
             <a:ext cx="1673352" cy="603504"/>
           </a:xfrm>
           <a:prstGeom prst="rect">
@@ -4073,8 +4073,8 @@
         </p:blipFill>
         <p:spPr>
           <a:xfrm>
-            <a:off x="4204312" y="3483068"/>
-            <a:ext cx="1292733" cy="664321"/>
+            <a:off x="4253917" y="3483068"/>
+            <a:ext cx="1193292" cy="613219"/>
           </a:xfrm>
           <a:prstGeom prst="rect">
             <a:avLst/>
@@ -4089,7 +4089,7 @@
         </p:nvSpPr>
         <p:spPr>
           <a:xfrm>
-            <a:off x="5497045" y="3586629"/>
+            <a:off x="5447209" y="3561078"/>
             <a:ext cx="2710042" cy="457200"/>
           </a:xfrm>
           <a:prstGeom prst="rect">
@@ -11560,8 +11560,8 @@
         </p:blipFill>
         <p:spPr>
           <a:xfrm>
-            <a:off x="2825106" y="3500959"/>
-            <a:ext cx="2705163" cy="664321"/>
+            <a:off x="2929036" y="3500959"/>
+            <a:ext cx="2497073" cy="613219"/>
           </a:xfrm>
           <a:prstGeom prst="rect">
             <a:avLst/>
@@ -11576,7 +11576,7 @@
         </p:nvSpPr>
         <p:spPr>
           <a:xfrm>
-            <a:off x="5530269" y="3604519"/>
+            <a:off x="5426110" y="3578969"/>
             <a:ext cx="4056024" cy="457200"/>
           </a:xfrm>
           <a:prstGeom prst="rect">
@@ -11619,8 +11619,8 @@
         </p:blipFill>
         <p:spPr>
           <a:xfrm>
-            <a:off x="2825106" y="4293296"/>
-            <a:ext cx="2163532" cy="661328"/>
+            <a:off x="2929036" y="4242194"/>
+            <a:ext cx="1997106" cy="610457"/>
           </a:xfrm>
           <a:prstGeom prst="rect">
             <a:avLst/>
@@ -11635,7 +11635,7 @@
         </p:nvSpPr>
         <p:spPr>
           <a:xfrm>
-            <a:off x="4988638" y="4395360"/>
+            <a:off x="4926142" y="4318823"/>
             <a:ext cx="3005336" cy="457200"/>
           </a:xfrm>
           <a:prstGeom prst="rect">
@@ -11670,7 +11670,7 @@
         </p:nvSpPr>
         <p:spPr>
           <a:xfrm>
-            <a:off x="777240" y="5091785"/>
+            <a:off x="777240" y="4989812"/>
             <a:ext cx="10607040" cy="1072896"/>
           </a:xfrm>
           <a:prstGeom prst="rect">
@@ -12959,8 +12959,8 @@
         </p:blipFill>
         <p:spPr>
           <a:xfrm>
-            <a:off x="3791781" y="3149114"/>
-            <a:ext cx="1487241" cy="272311"/>
+            <a:off x="3848868" y="3169601"/>
+            <a:ext cx="1372838" cy="251364"/>
           </a:xfrm>
           <a:prstGeom prst="rect">
             <a:avLst/>
@@ -12975,7 +12975,7 @@
         </p:nvSpPr>
         <p:spPr>
           <a:xfrm>
-            <a:off x="5279023" y="3048728"/>
+            <a:off x="5221706" y="3048728"/>
             <a:ext cx="3340595" cy="457200"/>
           </a:xfrm>
           <a:prstGeom prst="rect">
@@ -13018,7 +13018,7 @@
         </p:blipFill>
         <p:spPr>
           <a:xfrm>
-            <a:off x="3791781" y="3708049"/>
+            <a:off x="3848868" y="3708049"/>
             <a:ext cx="1453896" cy="252984"/>
           </a:xfrm>
           <a:prstGeom prst="rect">
@@ -13708,8 +13708,8 @@
         </p:blipFill>
         <p:spPr>
           <a:xfrm>
-            <a:off x="2543413" y="3071588"/>
-            <a:ext cx="1150282" cy="556180"/>
+            <a:off x="2587849" y="3071588"/>
+            <a:ext cx="1061799" cy="513397"/>
           </a:xfrm>
           <a:prstGeom prst="rect">
             <a:avLst/>
@@ -13724,7 +13724,7 @@
         </p:nvSpPr>
         <p:spPr>
           <a:xfrm>
-            <a:off x="3693695" y="3121079"/>
+            <a:off x="3649648" y="3099687"/>
             <a:ext cx="6166242" cy="457200"/>
           </a:xfrm>
           <a:prstGeom prst="rect">

</xml_diff>

<commit_message>
Rebuilt on the kit's airier Notes slides and wider separators; 0 findings, installed
Co-Authored-By: Claude Fable 5.1 <noreply@anthropic.com>
Claude-Session: https://claude.ai/code/session_01B7ovt6yLjh6QuFV9HBMV4N
</commit_message>
<xml_diff>
--- a/a7/build/out/u5/A7 5.01 Scale Drawings - Slides.pptx
+++ b/a7/build/out/u5/A7 5.01 Scale Drawings - Slides.pptx
@@ -16056,7 +16056,7 @@
       </p:cxnSp>
       <p:pic>
         <p:nvPicPr>
-          <p:cNvPr id="10" name="Picture 9" descr="ga37466dfaa18789a.png"/>
+          <p:cNvPr id="10" name="Picture 9" descr="g8cdf1f3d17875606.png"/>
           <p:cNvPicPr>
             <a:picLocks noChangeAspect="1"/>
           </p:cNvPicPr>
@@ -16070,8 +16070,8 @@
         </p:blipFill>
         <p:spPr>
           <a:xfrm>
-            <a:off x="3611879" y="1993392"/>
-            <a:ext cx="4937760" cy="2238451"/>
+            <a:off x="3794759" y="1993392"/>
+            <a:ext cx="4572000" cy="2072640"/>
           </a:xfrm>
           <a:prstGeom prst="rect">
             <a:avLst/>
@@ -16080,7 +16080,7 @@
       </p:pic>
       <p:pic>
         <p:nvPicPr>
-          <p:cNvPr id="11" name="Picture 10" descr="5db795a1dcbd5a67.png"/>
+          <p:cNvPr id="11" name="Picture 10" descr="3d90d3b02b60e6c0.png"/>
           <p:cNvPicPr>
             <a:picLocks noChangeAspect="1"/>
           </p:cNvPicPr>
@@ -16094,8 +16094,8 @@
         </p:blipFill>
         <p:spPr>
           <a:xfrm>
-            <a:off x="1670304" y="4378147"/>
-            <a:ext cx="8820912" cy="804672"/>
+            <a:off x="1315211" y="4212336"/>
+            <a:ext cx="9531096" cy="804672"/>
           </a:xfrm>
           <a:prstGeom prst="rect">
             <a:avLst/>
@@ -16110,7 +16110,7 @@
         </p:nvSpPr>
         <p:spPr>
           <a:xfrm>
-            <a:off x="987552" y="5521147"/>
+            <a:off x="987552" y="5355336"/>
             <a:ext cx="10131551" cy="475488"/>
           </a:xfrm>
           <a:prstGeom prst="rect">
@@ -16451,7 +16451,7 @@
         </p:blipFill>
         <p:spPr>
           <a:xfrm>
-            <a:off x="2630424" y="1993392"/>
+            <a:off x="2630424" y="2194560"/>
             <a:ext cx="6900672" cy="670560"/>
           </a:xfrm>
           <a:prstGeom prst="rect">
@@ -16467,7 +16467,7 @@
         </p:nvSpPr>
         <p:spPr>
           <a:xfrm>
-            <a:off x="987552" y="3002280"/>
+            <a:off x="987552" y="3404616"/>
             <a:ext cx="10131551" cy="950976"/>
           </a:xfrm>
           <a:prstGeom prst="rect">
@@ -16794,7 +16794,7 @@
       </p:cxnSp>
       <p:pic>
         <p:nvPicPr>
-          <p:cNvPr id="10" name="Picture 9" descr="9f2961e2a0098639.png"/>
+          <p:cNvPr id="10" name="Picture 9" descr="58c3ddc15ef61088.png"/>
           <p:cNvPicPr>
             <a:picLocks noChangeAspect="1"/>
           </p:cNvPicPr>
@@ -16808,8 +16808,8 @@
         </p:blipFill>
         <p:spPr>
           <a:xfrm>
-            <a:off x="2462784" y="2017776"/>
-            <a:ext cx="7235952" cy="387096"/>
+            <a:off x="2285999" y="2218944"/>
+            <a:ext cx="7589520" cy="387096"/>
           </a:xfrm>
           <a:prstGeom prst="rect">
             <a:avLst/>
@@ -16832,7 +16832,7 @@
         </p:blipFill>
         <p:spPr>
           <a:xfrm>
-            <a:off x="1667255" y="2713101"/>
+            <a:off x="1667255" y="3023997"/>
             <a:ext cx="8827008" cy="301752"/>
           </a:xfrm>
           <a:prstGeom prst="rect">
@@ -16848,7 +16848,7 @@
         </p:nvSpPr>
         <p:spPr>
           <a:xfrm>
-            <a:off x="987552" y="3429000"/>
+            <a:off x="987552" y="3941064"/>
             <a:ext cx="10131551" cy="475488"/>
           </a:xfrm>
           <a:prstGeom prst="rect">

</xml_diff>